<commit_message>
add fuente de datos en la presentación
</commit_message>
<xml_diff>
--- a/Equip_28/Results/Analisis_PAP_and_ABL_RapidExpres_2026_11_05.pptx
+++ b/Equip_28/Results/Analisis_PAP_and_ABL_RapidExpres_2026_11_05.pptx
@@ -19,14 +19,14 @@
     <p:sldId id="298" r:id="rId10"/>
     <p:sldId id="302" r:id="rId11"/>
     <p:sldId id="303" r:id="rId12"/>
-    <p:sldId id="297" r:id="rId13"/>
-    <p:sldId id="258" r:id="rId14"/>
-    <p:sldId id="260" r:id="rId15"/>
-    <p:sldId id="287" r:id="rId16"/>
-    <p:sldId id="284" r:id="rId17"/>
-    <p:sldId id="285" r:id="rId18"/>
-    <p:sldId id="295" r:id="rId19"/>
-    <p:sldId id="288" r:id="rId20"/>
+    <p:sldId id="288" r:id="rId13"/>
+    <p:sldId id="297" r:id="rId14"/>
+    <p:sldId id="258" r:id="rId15"/>
+    <p:sldId id="260" r:id="rId16"/>
+    <p:sldId id="287" r:id="rId17"/>
+    <p:sldId id="284" r:id="rId18"/>
+    <p:sldId id="285" r:id="rId19"/>
+    <p:sldId id="295" r:id="rId20"/>
     <p:sldId id="289" r:id="rId21"/>
     <p:sldId id="257" r:id="rId22"/>
     <p:sldId id="291" r:id="rId23"/>
@@ -1076,6 +1076,133 @@
   <p:cSld>
     <p:spTree>
       <p:nvGrpSpPr>
+        <p:cNvPr id="1" name="Shape 277">
+          <a:extLst>
+            <a:ext uri="{FF2B5EF4-FFF2-40B4-BE49-F238E27FC236}">
+              <a16:creationId xmlns:a16="http://schemas.microsoft.com/office/drawing/2014/main" id="{68033C6D-CA4B-39C8-3566-B3082BE34F0C}"/>
+            </a:ext>
+          </a:extLst>
+        </p:cNvPr>
+        <p:cNvGrpSpPr/>
+        <p:nvPr/>
+      </p:nvGrpSpPr>
+      <p:grpSpPr>
+        <a:xfrm>
+          <a:off x="0" y="0"/>
+          <a:ext cx="0" cy="0"/>
+          <a:chOff x="0" y="0"/>
+          <a:chExt cx="0" cy="0"/>
+        </a:xfrm>
+      </p:grpSpPr>
+      <p:sp>
+        <p:nvSpPr>
+          <p:cNvPr id="278" name="Google Shape;278;p11:notes">
+            <a:extLst>
+              <a:ext uri="{FF2B5EF4-FFF2-40B4-BE49-F238E27FC236}">
+                <a16:creationId xmlns:a16="http://schemas.microsoft.com/office/drawing/2014/main" id="{99F3EF2D-1DA0-6769-2A84-7EB054C8FA0D}"/>
+              </a:ext>
+            </a:extLst>
+          </p:cNvPr>
+          <p:cNvSpPr txBox="1">
+            <a:spLocks noGrp="1"/>
+          </p:cNvSpPr>
+          <p:nvPr>
+            <p:ph type="body" idx="1"/>
+          </p:nvPr>
+        </p:nvSpPr>
+        <p:spPr>
+          <a:xfrm>
+            <a:off x="685800" y="4343400"/>
+            <a:ext cx="5486400" cy="4114800"/>
+          </a:xfrm>
+          <a:prstGeom prst="rect">
+            <a:avLst/>
+          </a:prstGeom>
+        </p:spPr>
+        <p:txBody>
+          <a:bodyPr spcFirstLastPara="1" wrap="square" lIns="91425" tIns="91425" rIns="91425" bIns="91425" anchor="t" anchorCtr="0">
+            <a:noAutofit/>
+          </a:bodyPr>
+          <a:lstStyle/>
+          <a:p>
+            <a:pPr marL="0" lvl="0" indent="0" algn="l" rtl="0">
+              <a:spcBef>
+                <a:spcPts val="0"/>
+              </a:spcBef>
+              <a:spcAft>
+                <a:spcPts val="0"/>
+              </a:spcAft>
+              <a:buNone/>
+            </a:pPr>
+            <a:endParaRPr/>
+          </a:p>
+        </p:txBody>
+      </p:sp>
+      <p:sp>
+        <p:nvSpPr>
+          <p:cNvPr id="279" name="Google Shape;279;p11:notes">
+            <a:extLst>
+              <a:ext uri="{FF2B5EF4-FFF2-40B4-BE49-F238E27FC236}">
+                <a16:creationId xmlns:a16="http://schemas.microsoft.com/office/drawing/2014/main" id="{13F44B19-8F08-E089-5982-64FED72C4EBC}"/>
+              </a:ext>
+            </a:extLst>
+          </p:cNvPr>
+          <p:cNvSpPr>
+            <a:spLocks noGrp="1" noRot="1" noChangeAspect="1"/>
+          </p:cNvSpPr>
+          <p:nvPr>
+            <p:ph type="sldImg" idx="2"/>
+          </p:nvPr>
+        </p:nvSpPr>
+        <p:spPr>
+          <a:xfrm>
+            <a:off x="381000" y="685800"/>
+            <a:ext cx="6096000" cy="3429000"/>
+          </a:xfrm>
+          <a:custGeom>
+            <a:avLst/>
+            <a:gdLst/>
+            <a:ahLst/>
+            <a:cxnLst/>
+            <a:rect l="l" t="t" r="r" b="b"/>
+            <a:pathLst>
+              <a:path w="120000" h="120000" extrusionOk="0">
+                <a:moveTo>
+                  <a:pt x="0" y="0"/>
+                </a:moveTo>
+                <a:lnTo>
+                  <a:pt x="120000" y="0"/>
+                </a:lnTo>
+                <a:lnTo>
+                  <a:pt x="120000" y="120000"/>
+                </a:lnTo>
+                <a:lnTo>
+                  <a:pt x="0" y="120000"/>
+                </a:lnTo>
+                <a:close/>
+              </a:path>
+            </a:pathLst>
+          </a:custGeom>
+        </p:spPr>
+      </p:sp>
+    </p:spTree>
+    <p:extLst>
+      <p:ext uri="{BB962C8B-B14F-4D97-AF65-F5344CB8AC3E}">
+        <p14:creationId xmlns:p14="http://schemas.microsoft.com/office/powerpoint/2010/main" val="3042925861"/>
+      </p:ext>
+    </p:extLst>
+  </p:cSld>
+  <p:clrMapOvr>
+    <a:masterClrMapping/>
+  </p:clrMapOvr>
+</p:notes>
+</file>
+
+<file path=ppt/notesSlides/notesSlide13.xml><?xml version="1.0" encoding="utf-8"?>
+<p:notes xmlns:a="http://schemas.openxmlformats.org/drawingml/2006/main" xmlns:r="http://schemas.openxmlformats.org/officeDocument/2006/relationships" xmlns:p="http://schemas.openxmlformats.org/presentationml/2006/main" showMasterSp="0" showMasterPhAnim="0">
+  <p:cSld>
+    <p:spTree>
+      <p:nvGrpSpPr>
         <p:cNvPr id="1" name="Shape 80"/>
         <p:cNvGrpSpPr/>
         <p:nvPr/>
@@ -1180,7 +1307,7 @@
 </p:notes>
 </file>
 
-<file path=ppt/notesSlides/notesSlide13.xml><?xml version="1.0" encoding="utf-8"?>
+<file path=ppt/notesSlides/notesSlide14.xml><?xml version="1.0" encoding="utf-8"?>
 <p:notes xmlns:a="http://schemas.openxmlformats.org/drawingml/2006/main" xmlns:r="http://schemas.openxmlformats.org/officeDocument/2006/relationships" xmlns:p="http://schemas.openxmlformats.org/presentationml/2006/main" showMasterSp="0" showMasterPhAnim="0">
   <p:cSld>
     <p:spTree>
@@ -1284,7 +1411,7 @@
 </p:notes>
 </file>
 
-<file path=ppt/notesSlides/notesSlide14.xml><?xml version="1.0" encoding="utf-8"?>
+<file path=ppt/notesSlides/notesSlide15.xml><?xml version="1.0" encoding="utf-8"?>
 <p:notes xmlns:a="http://schemas.openxmlformats.org/drawingml/2006/main" xmlns:r="http://schemas.openxmlformats.org/officeDocument/2006/relationships" xmlns:p="http://schemas.openxmlformats.org/presentationml/2006/main" showMasterSp="0" showMasterPhAnim="0">
   <p:cSld>
     <p:spTree>
@@ -1388,7 +1515,7 @@
 </p:notes>
 </file>
 
-<file path=ppt/notesSlides/notesSlide15.xml><?xml version="1.0" encoding="utf-8"?>
+<file path=ppt/notesSlides/notesSlide16.xml><?xml version="1.0" encoding="utf-8"?>
 <p:notes xmlns:a="http://schemas.openxmlformats.org/drawingml/2006/main" xmlns:r="http://schemas.openxmlformats.org/officeDocument/2006/relationships" xmlns:p="http://schemas.openxmlformats.org/presentationml/2006/main" showMasterSp="0" showMasterPhAnim="0">
   <p:cSld>
     <p:spTree>
@@ -1515,7 +1642,7 @@
 </p:notes>
 </file>
 
-<file path=ppt/notesSlides/notesSlide16.xml><?xml version="1.0" encoding="utf-8"?>
+<file path=ppt/notesSlides/notesSlide17.xml><?xml version="1.0" encoding="utf-8"?>
 <p:notes xmlns:a="http://schemas.openxmlformats.org/drawingml/2006/main" xmlns:r="http://schemas.openxmlformats.org/officeDocument/2006/relationships" xmlns:p="http://schemas.openxmlformats.org/presentationml/2006/main" showMasterSp="0" showMasterPhAnim="0">
   <p:cSld>
     <p:spTree>
@@ -1633,133 +1760,6 @@
     <p:extLst>
       <p:ext uri="{BB962C8B-B14F-4D97-AF65-F5344CB8AC3E}">
         <p14:creationId xmlns:p14="http://schemas.microsoft.com/office/powerpoint/2010/main" val="2275216246"/>
-      </p:ext>
-    </p:extLst>
-  </p:cSld>
-  <p:clrMapOvr>
-    <a:masterClrMapping/>
-  </p:clrMapOvr>
-</p:notes>
-</file>
-
-<file path=ppt/notesSlides/notesSlide17.xml><?xml version="1.0" encoding="utf-8"?>
-<p:notes xmlns:a="http://schemas.openxmlformats.org/drawingml/2006/main" xmlns:r="http://schemas.openxmlformats.org/officeDocument/2006/relationships" xmlns:p="http://schemas.openxmlformats.org/presentationml/2006/main" showMasterSp="0" showMasterPhAnim="0">
-  <p:cSld>
-    <p:spTree>
-      <p:nvGrpSpPr>
-        <p:cNvPr id="1" name="Shape 157">
-          <a:extLst>
-            <a:ext uri="{FF2B5EF4-FFF2-40B4-BE49-F238E27FC236}">
-              <a16:creationId xmlns:a16="http://schemas.microsoft.com/office/drawing/2014/main" id="{FCF5328D-5EF3-B3C2-ED5D-E6B9C72C504A}"/>
-            </a:ext>
-          </a:extLst>
-        </p:cNvPr>
-        <p:cNvGrpSpPr/>
-        <p:nvPr/>
-      </p:nvGrpSpPr>
-      <p:grpSpPr>
-        <a:xfrm>
-          <a:off x="0" y="0"/>
-          <a:ext cx="0" cy="0"/>
-          <a:chOff x="0" y="0"/>
-          <a:chExt cx="0" cy="0"/>
-        </a:xfrm>
-      </p:grpSpPr>
-      <p:sp>
-        <p:nvSpPr>
-          <p:cNvPr id="158" name="Google Shape;158;p4:notes">
-            <a:extLst>
-              <a:ext uri="{FF2B5EF4-FFF2-40B4-BE49-F238E27FC236}">
-                <a16:creationId xmlns:a16="http://schemas.microsoft.com/office/drawing/2014/main" id="{2D46FA33-ABC3-5982-513A-88AF808BFDFD}"/>
-              </a:ext>
-            </a:extLst>
-          </p:cNvPr>
-          <p:cNvSpPr txBox="1">
-            <a:spLocks noGrp="1"/>
-          </p:cNvSpPr>
-          <p:nvPr>
-            <p:ph type="body" idx="1"/>
-          </p:nvPr>
-        </p:nvSpPr>
-        <p:spPr>
-          <a:xfrm>
-            <a:off x="685800" y="4343400"/>
-            <a:ext cx="5486400" cy="4114800"/>
-          </a:xfrm>
-          <a:prstGeom prst="rect">
-            <a:avLst/>
-          </a:prstGeom>
-        </p:spPr>
-        <p:txBody>
-          <a:bodyPr spcFirstLastPara="1" wrap="square" lIns="91425" tIns="91425" rIns="91425" bIns="91425" anchor="t" anchorCtr="0">
-            <a:noAutofit/>
-          </a:bodyPr>
-          <a:lstStyle/>
-          <a:p>
-            <a:pPr marL="0" lvl="0" indent="0" algn="l" rtl="0">
-              <a:spcBef>
-                <a:spcPts val="0"/>
-              </a:spcBef>
-              <a:spcAft>
-                <a:spcPts val="0"/>
-              </a:spcAft>
-              <a:buNone/>
-            </a:pPr>
-            <a:endParaRPr/>
-          </a:p>
-        </p:txBody>
-      </p:sp>
-      <p:sp>
-        <p:nvSpPr>
-          <p:cNvPr id="159" name="Google Shape;159;p4:notes">
-            <a:extLst>
-              <a:ext uri="{FF2B5EF4-FFF2-40B4-BE49-F238E27FC236}">
-                <a16:creationId xmlns:a16="http://schemas.microsoft.com/office/drawing/2014/main" id="{C456DE22-CE1E-6447-C306-D3F9178E76A0}"/>
-              </a:ext>
-            </a:extLst>
-          </p:cNvPr>
-          <p:cNvSpPr>
-            <a:spLocks noGrp="1" noRot="1" noChangeAspect="1"/>
-          </p:cNvSpPr>
-          <p:nvPr>
-            <p:ph type="sldImg" idx="2"/>
-          </p:nvPr>
-        </p:nvSpPr>
-        <p:spPr>
-          <a:xfrm>
-            <a:off x="381000" y="685800"/>
-            <a:ext cx="6096000" cy="3429000"/>
-          </a:xfrm>
-          <a:custGeom>
-            <a:avLst/>
-            <a:gdLst/>
-            <a:ahLst/>
-            <a:cxnLst/>
-            <a:rect l="l" t="t" r="r" b="b"/>
-            <a:pathLst>
-              <a:path w="120000" h="120000" extrusionOk="0">
-                <a:moveTo>
-                  <a:pt x="0" y="0"/>
-                </a:moveTo>
-                <a:lnTo>
-                  <a:pt x="120000" y="0"/>
-                </a:lnTo>
-                <a:lnTo>
-                  <a:pt x="120000" y="120000"/>
-                </a:lnTo>
-                <a:lnTo>
-                  <a:pt x="0" y="120000"/>
-                </a:lnTo>
-                <a:close/>
-              </a:path>
-            </a:pathLst>
-          </a:custGeom>
-        </p:spPr>
-      </p:sp>
-    </p:spTree>
-    <p:extLst>
-      <p:ext uri="{BB962C8B-B14F-4D97-AF65-F5344CB8AC3E}">
-        <p14:creationId xmlns:p14="http://schemas.microsoft.com/office/powerpoint/2010/main" val="3384843925"/>
       </p:ext>
     </p:extLst>
   </p:cSld>
@@ -1886,7 +1886,7 @@
     </p:spTree>
     <p:extLst>
       <p:ext uri="{BB962C8B-B14F-4D97-AF65-F5344CB8AC3E}">
-        <p14:creationId xmlns:p14="http://schemas.microsoft.com/office/powerpoint/2010/main" val="4038510907"/>
+        <p14:creationId xmlns:p14="http://schemas.microsoft.com/office/powerpoint/2010/main" val="3384843925"/>
       </p:ext>
     </p:extLst>
   </p:cSld>
@@ -1901,10 +1901,10 @@
   <p:cSld>
     <p:spTree>
       <p:nvGrpSpPr>
-        <p:cNvPr id="1" name="Shape 277">
+        <p:cNvPr id="1" name="Shape 157">
           <a:extLst>
             <a:ext uri="{FF2B5EF4-FFF2-40B4-BE49-F238E27FC236}">
-              <a16:creationId xmlns:a16="http://schemas.microsoft.com/office/drawing/2014/main" id="{68033C6D-CA4B-39C8-3566-B3082BE34F0C}"/>
+              <a16:creationId xmlns:a16="http://schemas.microsoft.com/office/drawing/2014/main" id="{FCF5328D-5EF3-B3C2-ED5D-E6B9C72C504A}"/>
             </a:ext>
           </a:extLst>
         </p:cNvPr>
@@ -1921,10 +1921,10 @@
       </p:grpSpPr>
       <p:sp>
         <p:nvSpPr>
-          <p:cNvPr id="278" name="Google Shape;278;p11:notes">
+          <p:cNvPr id="158" name="Google Shape;158;p4:notes">
             <a:extLst>
               <a:ext uri="{FF2B5EF4-FFF2-40B4-BE49-F238E27FC236}">
-                <a16:creationId xmlns:a16="http://schemas.microsoft.com/office/drawing/2014/main" id="{99F3EF2D-1DA0-6769-2A84-7EB054C8FA0D}"/>
+                <a16:creationId xmlns:a16="http://schemas.microsoft.com/office/drawing/2014/main" id="{2D46FA33-ABC3-5982-513A-88AF808BFDFD}"/>
               </a:ext>
             </a:extLst>
           </p:cNvPr>
@@ -1965,10 +1965,10 @@
       </p:sp>
       <p:sp>
         <p:nvSpPr>
-          <p:cNvPr id="279" name="Google Shape;279;p11:notes">
+          <p:cNvPr id="159" name="Google Shape;159;p4:notes">
             <a:extLst>
               <a:ext uri="{FF2B5EF4-FFF2-40B4-BE49-F238E27FC236}">
-                <a16:creationId xmlns:a16="http://schemas.microsoft.com/office/drawing/2014/main" id="{13F44B19-8F08-E089-5982-64FED72C4EBC}"/>
+                <a16:creationId xmlns:a16="http://schemas.microsoft.com/office/drawing/2014/main" id="{C456DE22-CE1E-6447-C306-D3F9178E76A0}"/>
               </a:ext>
             </a:extLst>
           </p:cNvPr>
@@ -2013,7 +2013,7 @@
     </p:spTree>
     <p:extLst>
       <p:ext uri="{BB962C8B-B14F-4D97-AF65-F5344CB8AC3E}">
-        <p14:creationId xmlns:p14="http://schemas.microsoft.com/office/powerpoint/2010/main" val="3042925861"/>
+        <p14:creationId xmlns:p14="http://schemas.microsoft.com/office/powerpoint/2010/main" val="4038510907"/>
       </p:ext>
     </p:extLst>
   </p:cSld>
@@ -14994,6 +14994,48 @@
           </a:prstGeom>
         </p:spPr>
       </p:pic>
+      <p:sp>
+        <p:nvSpPr>
+          <p:cNvPr id="9" name="QuadreDeText 8">
+            <a:extLst>
+              <a:ext uri="{FF2B5EF4-FFF2-40B4-BE49-F238E27FC236}">
+                <a16:creationId xmlns:a16="http://schemas.microsoft.com/office/drawing/2014/main" id="{94872647-7527-45A5-AB2A-5C75504F1D1F}"/>
+              </a:ext>
+            </a:extLst>
+          </p:cNvPr>
+          <p:cNvSpPr txBox="1"/>
+          <p:nvPr/>
+        </p:nvSpPr>
+        <p:spPr>
+          <a:xfrm>
+            <a:off x="11857218" y="9787306"/>
+            <a:ext cx="9233942" cy="307777"/>
+          </a:xfrm>
+          <a:prstGeom prst="rect">
+            <a:avLst/>
+          </a:prstGeom>
+          <a:noFill/>
+        </p:spPr>
+        <p:txBody>
+          <a:bodyPr wrap="square">
+            <a:spAutoFit/>
+          </a:bodyPr>
+          <a:lstStyle/>
+          <a:p>
+            <a:r>
+              <a:rPr lang="es-ES" dirty="0"/>
+              <a:t>Fuente: </a:t>
+            </a:r>
+            <a:r>
+              <a:rPr lang="es-ES" dirty="0">
+                <a:hlinkClick r:id="rId6"/>
+              </a:rPr>
+              <a:t>Encuesta Anual Laboral. Ministerio de Trabajo y Economía Social</a:t>
+            </a:r>
+            <a:endParaRPr lang="es-ES" dirty="0"/>
+          </a:p>
+        </p:txBody>
+      </p:sp>
     </p:spTree>
     <p:extLst>
       <p:ext uri="{BB962C8B-B14F-4D97-AF65-F5344CB8AC3E}">
@@ -15008,6 +15050,980 @@
 </file>
 
 <file path=ppt/slides/slide12.xml><?xml version="1.0" encoding="utf-8"?>
+<p:sld xmlns:a="http://schemas.openxmlformats.org/drawingml/2006/main" xmlns:r="http://schemas.openxmlformats.org/officeDocument/2006/relationships" xmlns:p="http://schemas.openxmlformats.org/presentationml/2006/main">
+  <p:cSld>
+    <p:bg>
+      <p:bgPr>
+        <a:solidFill>
+          <a:srgbClr val="E0E9F9"/>
+        </a:solidFill>
+        <a:effectLst/>
+      </p:bgPr>
+    </p:bg>
+    <p:spTree>
+      <p:nvGrpSpPr>
+        <p:cNvPr id="1" name="Shape 280">
+          <a:extLst>
+            <a:ext uri="{FF2B5EF4-FFF2-40B4-BE49-F238E27FC236}">
+              <a16:creationId xmlns:a16="http://schemas.microsoft.com/office/drawing/2014/main" id="{9CF05CD1-42CF-1415-2507-014F0D5DAD6D}"/>
+            </a:ext>
+          </a:extLst>
+        </p:cNvPr>
+        <p:cNvGrpSpPr/>
+        <p:nvPr/>
+      </p:nvGrpSpPr>
+      <p:grpSpPr>
+        <a:xfrm>
+          <a:off x="0" y="0"/>
+          <a:ext cx="0" cy="0"/>
+          <a:chOff x="0" y="0"/>
+          <a:chExt cx="0" cy="0"/>
+        </a:xfrm>
+      </p:grpSpPr>
+      <p:grpSp>
+        <p:nvGrpSpPr>
+          <p:cNvPr id="281" name="Google Shape;281;p23">
+            <a:extLst>
+              <a:ext uri="{FF2B5EF4-FFF2-40B4-BE49-F238E27FC236}">
+                <a16:creationId xmlns:a16="http://schemas.microsoft.com/office/drawing/2014/main" id="{FBD2D488-777B-F881-321D-7414A6F7B18A}"/>
+              </a:ext>
+            </a:extLst>
+          </p:cNvPr>
+          <p:cNvGrpSpPr/>
+          <p:nvPr/>
+        </p:nvGrpSpPr>
+        <p:grpSpPr>
+          <a:xfrm>
+            <a:off x="8647101" y="1554020"/>
+            <a:ext cx="1382928" cy="1389712"/>
+            <a:chOff x="0" y="-9525"/>
+            <a:chExt cx="963809" cy="968537"/>
+          </a:xfrm>
+        </p:grpSpPr>
+        <p:sp>
+          <p:nvSpPr>
+            <p:cNvPr id="282" name="Google Shape;282;p23">
+              <a:extLst>
+                <a:ext uri="{FF2B5EF4-FFF2-40B4-BE49-F238E27FC236}">
+                  <a16:creationId xmlns:a16="http://schemas.microsoft.com/office/drawing/2014/main" id="{0904FE46-466E-A0FE-64A7-933E7269DDAC}"/>
+                </a:ext>
+              </a:extLst>
+            </p:cNvPr>
+            <p:cNvSpPr/>
+            <p:nvPr/>
+          </p:nvSpPr>
+          <p:spPr>
+            <a:xfrm>
+              <a:off x="0" y="0"/>
+              <a:ext cx="963809" cy="959012"/>
+            </a:xfrm>
+            <a:custGeom>
+              <a:avLst/>
+              <a:gdLst/>
+              <a:ahLst/>
+              <a:cxnLst/>
+              <a:rect l="l" t="t" r="r" b="b"/>
+              <a:pathLst>
+                <a:path w="963809" h="959012" extrusionOk="0">
+                  <a:moveTo>
+                    <a:pt x="0" y="0"/>
+                  </a:moveTo>
+                  <a:lnTo>
+                    <a:pt x="963809" y="0"/>
+                  </a:lnTo>
+                  <a:lnTo>
+                    <a:pt x="963809" y="959012"/>
+                  </a:lnTo>
+                  <a:lnTo>
+                    <a:pt x="0" y="959012"/>
+                  </a:lnTo>
+                  <a:close/>
+                </a:path>
+              </a:pathLst>
+            </a:custGeom>
+            <a:solidFill>
+              <a:srgbClr val="FFFFFF"/>
+            </a:solidFill>
+            <a:ln w="28575" cap="sq" cmpd="sng">
+              <a:solidFill>
+                <a:srgbClr val="004AAD"/>
+              </a:solidFill>
+              <a:prstDash val="solid"/>
+              <a:miter lim="8000"/>
+              <a:headEnd type="none" w="sm" len="sm"/>
+              <a:tailEnd type="none" w="sm" len="sm"/>
+            </a:ln>
+          </p:spPr>
+          <p:txBody>
+            <a:bodyPr/>
+            <a:lstStyle/>
+            <a:p>
+              <a:endParaRPr lang="es-ES_tradnl" dirty="0"/>
+            </a:p>
+          </p:txBody>
+        </p:sp>
+        <p:sp>
+          <p:nvSpPr>
+            <p:cNvPr id="283" name="Google Shape;283;p23">
+              <a:extLst>
+                <a:ext uri="{FF2B5EF4-FFF2-40B4-BE49-F238E27FC236}">
+                  <a16:creationId xmlns:a16="http://schemas.microsoft.com/office/drawing/2014/main" id="{35B35C79-17F9-73C2-E425-160AB7E1FED4}"/>
+                </a:ext>
+              </a:extLst>
+            </p:cNvPr>
+            <p:cNvSpPr txBox="1"/>
+            <p:nvPr/>
+          </p:nvSpPr>
+          <p:spPr>
+            <a:xfrm>
+              <a:off x="0" y="-9525"/>
+              <a:ext cx="963809" cy="968537"/>
+            </a:xfrm>
+            <a:prstGeom prst="rect">
+              <a:avLst/>
+            </a:prstGeom>
+            <a:noFill/>
+            <a:ln>
+              <a:noFill/>
+            </a:ln>
+          </p:spPr>
+          <p:txBody>
+            <a:bodyPr spcFirstLastPara="1" wrap="square" lIns="50800" tIns="50800" rIns="50800" bIns="50800" anchor="ctr" anchorCtr="0">
+              <a:noAutofit/>
+            </a:bodyPr>
+            <a:lstStyle/>
+            <a:p>
+              <a:pPr marL="0" marR="0" lvl="0" indent="0" algn="ctr" rtl="0">
+                <a:lnSpc>
+                  <a:spcPct val="113000"/>
+                </a:lnSpc>
+                <a:spcBef>
+                  <a:spcPts val="0"/>
+                </a:spcBef>
+                <a:spcAft>
+                  <a:spcPts val="0"/>
+                </a:spcAft>
+                <a:buNone/>
+              </a:pPr>
+              <a:r>
+                <a:rPr lang="es-ES_tradnl" sz="5000" b="1" i="0" u="none" strike="noStrike" cap="none" dirty="0">
+                  <a:solidFill>
+                    <a:srgbClr val="004AAD"/>
+                  </a:solidFill>
+                  <a:latin typeface="Poppins Black"/>
+                  <a:ea typeface="Poppins Black"/>
+                  <a:cs typeface="Poppins Black"/>
+                  <a:sym typeface="Poppins Black"/>
+                </a:rPr>
+                <a:t>1</a:t>
+              </a:r>
+              <a:endParaRPr lang="es-ES_tradnl" dirty="0"/>
+            </a:p>
+          </p:txBody>
+        </p:sp>
+      </p:grpSp>
+      <p:grpSp>
+        <p:nvGrpSpPr>
+          <p:cNvPr id="284" name="Google Shape;284;p23">
+            <a:extLst>
+              <a:ext uri="{FF2B5EF4-FFF2-40B4-BE49-F238E27FC236}">
+                <a16:creationId xmlns:a16="http://schemas.microsoft.com/office/drawing/2014/main" id="{D4DCD8B5-19F0-0D56-7A66-19EBF123EFC1}"/>
+              </a:ext>
+            </a:extLst>
+          </p:cNvPr>
+          <p:cNvGrpSpPr/>
+          <p:nvPr/>
+        </p:nvGrpSpPr>
+        <p:grpSpPr>
+          <a:xfrm>
+            <a:off x="8647101" y="3546536"/>
+            <a:ext cx="1382928" cy="1389712"/>
+            <a:chOff x="0" y="-9525"/>
+            <a:chExt cx="963809" cy="968537"/>
+          </a:xfrm>
+        </p:grpSpPr>
+        <p:sp>
+          <p:nvSpPr>
+            <p:cNvPr id="285" name="Google Shape;285;p23">
+              <a:extLst>
+                <a:ext uri="{FF2B5EF4-FFF2-40B4-BE49-F238E27FC236}">
+                  <a16:creationId xmlns:a16="http://schemas.microsoft.com/office/drawing/2014/main" id="{D9191FA8-EB35-68D8-CBB9-8124915F3660}"/>
+                </a:ext>
+              </a:extLst>
+            </p:cNvPr>
+            <p:cNvSpPr/>
+            <p:nvPr/>
+          </p:nvSpPr>
+          <p:spPr>
+            <a:xfrm>
+              <a:off x="0" y="0"/>
+              <a:ext cx="963809" cy="959012"/>
+            </a:xfrm>
+            <a:custGeom>
+              <a:avLst/>
+              <a:gdLst/>
+              <a:ahLst/>
+              <a:cxnLst/>
+              <a:rect l="l" t="t" r="r" b="b"/>
+              <a:pathLst>
+                <a:path w="963809" h="959012" extrusionOk="0">
+                  <a:moveTo>
+                    <a:pt x="0" y="0"/>
+                  </a:moveTo>
+                  <a:lnTo>
+                    <a:pt x="963809" y="0"/>
+                  </a:lnTo>
+                  <a:lnTo>
+                    <a:pt x="963809" y="959012"/>
+                  </a:lnTo>
+                  <a:lnTo>
+                    <a:pt x="0" y="959012"/>
+                  </a:lnTo>
+                  <a:close/>
+                </a:path>
+              </a:pathLst>
+            </a:custGeom>
+            <a:solidFill>
+              <a:srgbClr val="FFFFFF"/>
+            </a:solidFill>
+            <a:ln w="28575" cap="sq" cmpd="sng">
+              <a:solidFill>
+                <a:srgbClr val="004AAD"/>
+              </a:solidFill>
+              <a:prstDash val="solid"/>
+              <a:miter lim="8000"/>
+              <a:headEnd type="none" w="sm" len="sm"/>
+              <a:tailEnd type="none" w="sm" len="sm"/>
+            </a:ln>
+          </p:spPr>
+          <p:txBody>
+            <a:bodyPr/>
+            <a:lstStyle/>
+            <a:p>
+              <a:endParaRPr lang="es-ES_tradnl" dirty="0"/>
+            </a:p>
+          </p:txBody>
+        </p:sp>
+        <p:sp>
+          <p:nvSpPr>
+            <p:cNvPr id="286" name="Google Shape;286;p23">
+              <a:extLst>
+                <a:ext uri="{FF2B5EF4-FFF2-40B4-BE49-F238E27FC236}">
+                  <a16:creationId xmlns:a16="http://schemas.microsoft.com/office/drawing/2014/main" id="{5D2F282B-5CFE-6353-0E3A-8E7AC934BA03}"/>
+                </a:ext>
+              </a:extLst>
+            </p:cNvPr>
+            <p:cNvSpPr txBox="1"/>
+            <p:nvPr/>
+          </p:nvSpPr>
+          <p:spPr>
+            <a:xfrm>
+              <a:off x="0" y="-9525"/>
+              <a:ext cx="963809" cy="968537"/>
+            </a:xfrm>
+            <a:prstGeom prst="rect">
+              <a:avLst/>
+            </a:prstGeom>
+            <a:noFill/>
+            <a:ln>
+              <a:noFill/>
+            </a:ln>
+          </p:spPr>
+          <p:txBody>
+            <a:bodyPr spcFirstLastPara="1" wrap="square" lIns="50800" tIns="50800" rIns="50800" bIns="50800" anchor="ctr" anchorCtr="0">
+              <a:noAutofit/>
+            </a:bodyPr>
+            <a:lstStyle/>
+            <a:p>
+              <a:pPr marL="0" marR="0" lvl="0" indent="0" algn="ctr" rtl="0">
+                <a:lnSpc>
+                  <a:spcPct val="113000"/>
+                </a:lnSpc>
+                <a:spcBef>
+                  <a:spcPts val="0"/>
+                </a:spcBef>
+                <a:spcAft>
+                  <a:spcPts val="0"/>
+                </a:spcAft>
+                <a:buNone/>
+              </a:pPr>
+              <a:r>
+                <a:rPr lang="es-ES_tradnl" sz="5000" b="1" i="0" u="none" strike="noStrike" cap="none" dirty="0">
+                  <a:solidFill>
+                    <a:srgbClr val="004AAD"/>
+                  </a:solidFill>
+                  <a:latin typeface="Poppins Black"/>
+                  <a:ea typeface="Poppins Black"/>
+                  <a:cs typeface="Poppins Black"/>
+                  <a:sym typeface="Poppins Black"/>
+                </a:rPr>
+                <a:t>2</a:t>
+              </a:r>
+              <a:endParaRPr lang="es-ES_tradnl" dirty="0"/>
+            </a:p>
+          </p:txBody>
+        </p:sp>
+      </p:grpSp>
+      <p:grpSp>
+        <p:nvGrpSpPr>
+          <p:cNvPr id="287" name="Google Shape;287;p23">
+            <a:extLst>
+              <a:ext uri="{FF2B5EF4-FFF2-40B4-BE49-F238E27FC236}">
+                <a16:creationId xmlns:a16="http://schemas.microsoft.com/office/drawing/2014/main" id="{736B4F0E-699C-B9C6-CB17-B4A44D8566BE}"/>
+              </a:ext>
+            </a:extLst>
+          </p:cNvPr>
+          <p:cNvGrpSpPr/>
+          <p:nvPr/>
+        </p:nvGrpSpPr>
+        <p:grpSpPr>
+          <a:xfrm>
+            <a:off x="8647101" y="5578255"/>
+            <a:ext cx="1382928" cy="1389712"/>
+            <a:chOff x="0" y="-9525"/>
+            <a:chExt cx="963809" cy="968537"/>
+          </a:xfrm>
+        </p:grpSpPr>
+        <p:sp>
+          <p:nvSpPr>
+            <p:cNvPr id="288" name="Google Shape;288;p23">
+              <a:extLst>
+                <a:ext uri="{FF2B5EF4-FFF2-40B4-BE49-F238E27FC236}">
+                  <a16:creationId xmlns:a16="http://schemas.microsoft.com/office/drawing/2014/main" id="{534FAD3D-081E-452B-11A8-EF8FC4505649}"/>
+                </a:ext>
+              </a:extLst>
+            </p:cNvPr>
+            <p:cNvSpPr/>
+            <p:nvPr/>
+          </p:nvSpPr>
+          <p:spPr>
+            <a:xfrm>
+              <a:off x="0" y="0"/>
+              <a:ext cx="963809" cy="959012"/>
+            </a:xfrm>
+            <a:custGeom>
+              <a:avLst/>
+              <a:gdLst/>
+              <a:ahLst/>
+              <a:cxnLst/>
+              <a:rect l="l" t="t" r="r" b="b"/>
+              <a:pathLst>
+                <a:path w="963809" h="959012" extrusionOk="0">
+                  <a:moveTo>
+                    <a:pt x="0" y="0"/>
+                  </a:moveTo>
+                  <a:lnTo>
+                    <a:pt x="963809" y="0"/>
+                  </a:lnTo>
+                  <a:lnTo>
+                    <a:pt x="963809" y="959012"/>
+                  </a:lnTo>
+                  <a:lnTo>
+                    <a:pt x="0" y="959012"/>
+                  </a:lnTo>
+                  <a:close/>
+                </a:path>
+              </a:pathLst>
+            </a:custGeom>
+            <a:solidFill>
+              <a:srgbClr val="FFFFFF"/>
+            </a:solidFill>
+            <a:ln w="28575" cap="sq" cmpd="sng">
+              <a:solidFill>
+                <a:srgbClr val="004AAD"/>
+              </a:solidFill>
+              <a:prstDash val="solid"/>
+              <a:miter lim="8000"/>
+              <a:headEnd type="none" w="sm" len="sm"/>
+              <a:tailEnd type="none" w="sm" len="sm"/>
+            </a:ln>
+          </p:spPr>
+          <p:txBody>
+            <a:bodyPr/>
+            <a:lstStyle/>
+            <a:p>
+              <a:endParaRPr lang="es-ES_tradnl" dirty="0"/>
+            </a:p>
+          </p:txBody>
+        </p:sp>
+        <p:sp>
+          <p:nvSpPr>
+            <p:cNvPr id="289" name="Google Shape;289;p23">
+              <a:extLst>
+                <a:ext uri="{FF2B5EF4-FFF2-40B4-BE49-F238E27FC236}">
+                  <a16:creationId xmlns:a16="http://schemas.microsoft.com/office/drawing/2014/main" id="{F1D1B048-040C-1AF5-81F9-0F64D112826F}"/>
+                </a:ext>
+              </a:extLst>
+            </p:cNvPr>
+            <p:cNvSpPr txBox="1"/>
+            <p:nvPr/>
+          </p:nvSpPr>
+          <p:spPr>
+            <a:xfrm>
+              <a:off x="0" y="-9525"/>
+              <a:ext cx="963809" cy="968537"/>
+            </a:xfrm>
+            <a:prstGeom prst="rect">
+              <a:avLst/>
+            </a:prstGeom>
+            <a:noFill/>
+            <a:ln>
+              <a:noFill/>
+            </a:ln>
+          </p:spPr>
+          <p:txBody>
+            <a:bodyPr spcFirstLastPara="1" wrap="square" lIns="50800" tIns="50800" rIns="50800" bIns="50800" anchor="ctr" anchorCtr="0">
+              <a:noAutofit/>
+            </a:bodyPr>
+            <a:lstStyle/>
+            <a:p>
+              <a:pPr marL="0" marR="0" lvl="0" indent="0" algn="ctr" rtl="0">
+                <a:lnSpc>
+                  <a:spcPct val="113000"/>
+                </a:lnSpc>
+                <a:spcBef>
+                  <a:spcPts val="0"/>
+                </a:spcBef>
+                <a:spcAft>
+                  <a:spcPts val="0"/>
+                </a:spcAft>
+                <a:buNone/>
+              </a:pPr>
+              <a:r>
+                <a:rPr lang="es-ES_tradnl" sz="5000" b="1" i="0" u="none" strike="noStrike" cap="none" dirty="0">
+                  <a:solidFill>
+                    <a:srgbClr val="004AAD"/>
+                  </a:solidFill>
+                  <a:latin typeface="Poppins Black"/>
+                  <a:ea typeface="Poppins Black"/>
+                  <a:cs typeface="Poppins Black"/>
+                  <a:sym typeface="Poppins Black"/>
+                </a:rPr>
+                <a:t>3</a:t>
+              </a:r>
+              <a:endParaRPr lang="es-ES_tradnl" dirty="0"/>
+            </a:p>
+          </p:txBody>
+        </p:sp>
+      </p:grpSp>
+      <p:sp>
+        <p:nvSpPr>
+          <p:cNvPr id="293" name="Google Shape;293;p23">
+            <a:extLst>
+              <a:ext uri="{FF2B5EF4-FFF2-40B4-BE49-F238E27FC236}">
+                <a16:creationId xmlns:a16="http://schemas.microsoft.com/office/drawing/2014/main" id="{FFFE66FB-28AD-1476-E82E-46A9B8533C7C}"/>
+              </a:ext>
+            </a:extLst>
+          </p:cNvPr>
+          <p:cNvSpPr/>
+          <p:nvPr/>
+        </p:nvSpPr>
+        <p:spPr>
+          <a:xfrm>
+            <a:off x="-1518115" y="5138796"/>
+            <a:ext cx="7760440" cy="6137802"/>
+          </a:xfrm>
+          <a:custGeom>
+            <a:avLst/>
+            <a:gdLst/>
+            <a:ahLst/>
+            <a:cxnLst/>
+            <a:rect l="l" t="t" r="r" b="b"/>
+            <a:pathLst>
+              <a:path w="7760440" h="6137802" extrusionOk="0">
+                <a:moveTo>
+                  <a:pt x="0" y="0"/>
+                </a:moveTo>
+                <a:lnTo>
+                  <a:pt x="7760439" y="0"/>
+                </a:lnTo>
+                <a:lnTo>
+                  <a:pt x="7760439" y="6137802"/>
+                </a:lnTo>
+                <a:lnTo>
+                  <a:pt x="0" y="6137802"/>
+                </a:lnTo>
+                <a:lnTo>
+                  <a:pt x="0" y="0"/>
+                </a:lnTo>
+                <a:close/>
+              </a:path>
+            </a:pathLst>
+          </a:custGeom>
+          <a:blipFill rotWithShape="1">
+            <a:blip r:embed="rId3">
+              <a:alphaModFix/>
+            </a:blip>
+            <a:stretch>
+              <a:fillRect/>
+            </a:stretch>
+          </a:blipFill>
+          <a:ln>
+            <a:noFill/>
+          </a:ln>
+        </p:spPr>
+        <p:txBody>
+          <a:bodyPr/>
+          <a:lstStyle/>
+          <a:p>
+            <a:endParaRPr lang="es-ES_tradnl" dirty="0"/>
+          </a:p>
+        </p:txBody>
+      </p:sp>
+      <p:sp>
+        <p:nvSpPr>
+          <p:cNvPr id="294" name="Google Shape;294;p23">
+            <a:extLst>
+              <a:ext uri="{FF2B5EF4-FFF2-40B4-BE49-F238E27FC236}">
+                <a16:creationId xmlns:a16="http://schemas.microsoft.com/office/drawing/2014/main" id="{4335AF22-10B3-0245-6A1E-A7044BFDA00C}"/>
+              </a:ext>
+            </a:extLst>
+          </p:cNvPr>
+          <p:cNvSpPr txBox="1"/>
+          <p:nvPr/>
+        </p:nvSpPr>
+        <p:spPr>
+          <a:xfrm>
+            <a:off x="1357220" y="2067019"/>
+            <a:ext cx="5989500" cy="2011513"/>
+          </a:xfrm>
+          <a:prstGeom prst="rect">
+            <a:avLst/>
+          </a:prstGeom>
+          <a:noFill/>
+          <a:ln>
+            <a:noFill/>
+          </a:ln>
+        </p:spPr>
+        <p:txBody>
+          <a:bodyPr spcFirstLastPara="1" wrap="square" lIns="0" tIns="0" rIns="0" bIns="0" anchor="t" anchorCtr="0">
+            <a:spAutoFit/>
+          </a:bodyPr>
+          <a:lstStyle/>
+          <a:p>
+            <a:pPr marL="0" marR="0" lvl="0" indent="0" algn="l" rtl="0">
+              <a:lnSpc>
+                <a:spcPct val="121055"/>
+              </a:lnSpc>
+              <a:spcBef>
+                <a:spcPts val="0"/>
+              </a:spcBef>
+              <a:spcAft>
+                <a:spcPts val="0"/>
+              </a:spcAft>
+              <a:buNone/>
+            </a:pPr>
+            <a:r>
+              <a:rPr lang="es-ES_tradnl" sz="3601" b="1" dirty="0">
+                <a:solidFill>
+                  <a:srgbClr val="004AAD"/>
+                </a:solidFill>
+                <a:latin typeface="Poppins"/>
+                <a:ea typeface="Poppins"/>
+                <a:cs typeface="Poppins"/>
+                <a:sym typeface="Poppins"/>
+              </a:rPr>
+              <a:t>ESTRATEGIAS DE FORMACIÓNES ORGANIZACIONALES</a:t>
+            </a:r>
+            <a:endParaRPr lang="es-ES_tradnl" dirty="0"/>
+          </a:p>
+        </p:txBody>
+      </p:sp>
+      <p:sp>
+        <p:nvSpPr>
+          <p:cNvPr id="298" name="Google Shape;298;p23">
+            <a:extLst>
+              <a:ext uri="{FF2B5EF4-FFF2-40B4-BE49-F238E27FC236}">
+                <a16:creationId xmlns:a16="http://schemas.microsoft.com/office/drawing/2014/main" id="{186A78B8-C8E3-38CC-833A-72225D4995D6}"/>
+              </a:ext>
+            </a:extLst>
+          </p:cNvPr>
+          <p:cNvSpPr txBox="1"/>
+          <p:nvPr/>
+        </p:nvSpPr>
+        <p:spPr>
+          <a:xfrm>
+            <a:off x="10393716" y="2031037"/>
+            <a:ext cx="5989502" cy="878959"/>
+          </a:xfrm>
+          <a:prstGeom prst="rect">
+            <a:avLst/>
+          </a:prstGeom>
+          <a:noFill/>
+          <a:ln>
+            <a:noFill/>
+          </a:ln>
+        </p:spPr>
+        <p:txBody>
+          <a:bodyPr spcFirstLastPara="1" wrap="square" lIns="0" tIns="0" rIns="0" bIns="0" anchor="t" anchorCtr="0">
+            <a:spAutoFit/>
+          </a:bodyPr>
+          <a:lstStyle/>
+          <a:p>
+            <a:pPr marL="0" marR="0" lvl="1" indent="0" algn="l" rtl="0">
+              <a:lnSpc>
+                <a:spcPct val="119000"/>
+              </a:lnSpc>
+              <a:spcBef>
+                <a:spcPts val="0"/>
+              </a:spcBef>
+              <a:spcAft>
+                <a:spcPts val="0"/>
+              </a:spcAft>
+              <a:buNone/>
+            </a:pPr>
+            <a:r>
+              <a:rPr lang="es-ES_tradnl" sz="2400" b="1" i="0" u="none" strike="noStrike" cap="none" dirty="0">
+                <a:solidFill>
+                  <a:srgbClr val="004AAD"/>
+                </a:solidFill>
+                <a:latin typeface="Poppins"/>
+                <a:ea typeface="Poppins"/>
+                <a:cs typeface="Poppins"/>
+                <a:sym typeface="Poppins"/>
+              </a:rPr>
+              <a:t>APLANAMIENTO DE LA CURVA DE TRABAJO</a:t>
+            </a:r>
+            <a:endParaRPr lang="es-ES_tradnl" dirty="0"/>
+          </a:p>
+        </p:txBody>
+      </p:sp>
+      <p:sp>
+        <p:nvSpPr>
+          <p:cNvPr id="301" name="Google Shape;301;p23">
+            <a:extLst>
+              <a:ext uri="{FF2B5EF4-FFF2-40B4-BE49-F238E27FC236}">
+                <a16:creationId xmlns:a16="http://schemas.microsoft.com/office/drawing/2014/main" id="{0EB0886F-3824-8864-5A8D-63D9B2DF248C}"/>
+              </a:ext>
+            </a:extLst>
+          </p:cNvPr>
+          <p:cNvSpPr txBox="1"/>
+          <p:nvPr/>
+        </p:nvSpPr>
+        <p:spPr>
+          <a:xfrm>
+            <a:off x="10393716" y="4021652"/>
+            <a:ext cx="5989502" cy="439479"/>
+          </a:xfrm>
+          <a:prstGeom prst="rect">
+            <a:avLst/>
+          </a:prstGeom>
+          <a:noFill/>
+          <a:ln>
+            <a:noFill/>
+          </a:ln>
+        </p:spPr>
+        <p:txBody>
+          <a:bodyPr spcFirstLastPara="1" wrap="square" lIns="0" tIns="0" rIns="0" bIns="0" anchor="t" anchorCtr="0">
+            <a:spAutoFit/>
+          </a:bodyPr>
+          <a:lstStyle/>
+          <a:p>
+            <a:pPr marL="0" marR="0" lvl="1" indent="0" algn="l" rtl="0">
+              <a:lnSpc>
+                <a:spcPct val="119000"/>
+              </a:lnSpc>
+              <a:spcBef>
+                <a:spcPts val="0"/>
+              </a:spcBef>
+              <a:spcAft>
+                <a:spcPts val="0"/>
+              </a:spcAft>
+              <a:buNone/>
+            </a:pPr>
+            <a:r>
+              <a:rPr lang="es-ES_tradnl" sz="2400" b="1" i="0" u="none" strike="noStrike" cap="none" dirty="0">
+                <a:solidFill>
+                  <a:srgbClr val="004AAD"/>
+                </a:solidFill>
+                <a:latin typeface="Poppins"/>
+                <a:ea typeface="Poppins"/>
+                <a:cs typeface="Poppins"/>
+                <a:sym typeface="Poppins"/>
+              </a:rPr>
+              <a:t>PLANIFICACIÓN ESTACIONAL</a:t>
+            </a:r>
+            <a:endParaRPr lang="es-ES_tradnl" dirty="0"/>
+          </a:p>
+        </p:txBody>
+      </p:sp>
+      <p:sp>
+        <p:nvSpPr>
+          <p:cNvPr id="304" name="Google Shape;304;p23">
+            <a:extLst>
+              <a:ext uri="{FF2B5EF4-FFF2-40B4-BE49-F238E27FC236}">
+                <a16:creationId xmlns:a16="http://schemas.microsoft.com/office/drawing/2014/main" id="{D81F7156-2EA7-892B-78D9-A6A96CEF51FB}"/>
+              </a:ext>
+            </a:extLst>
+          </p:cNvPr>
+          <p:cNvSpPr txBox="1"/>
+          <p:nvPr/>
+        </p:nvSpPr>
+        <p:spPr>
+          <a:xfrm>
+            <a:off x="10393716" y="6053371"/>
+            <a:ext cx="5989502" cy="439479"/>
+          </a:xfrm>
+          <a:prstGeom prst="rect">
+            <a:avLst/>
+          </a:prstGeom>
+          <a:noFill/>
+          <a:ln>
+            <a:noFill/>
+          </a:ln>
+        </p:spPr>
+        <p:txBody>
+          <a:bodyPr spcFirstLastPara="1" wrap="square" lIns="0" tIns="0" rIns="0" bIns="0" anchor="t" anchorCtr="0">
+            <a:spAutoFit/>
+          </a:bodyPr>
+          <a:lstStyle/>
+          <a:p>
+            <a:pPr marL="0" marR="0" lvl="1" indent="0" algn="l" rtl="0">
+              <a:lnSpc>
+                <a:spcPct val="119000"/>
+              </a:lnSpc>
+              <a:spcBef>
+                <a:spcPts val="0"/>
+              </a:spcBef>
+              <a:spcAft>
+                <a:spcPts val="0"/>
+              </a:spcAft>
+              <a:buNone/>
+            </a:pPr>
+            <a:r>
+              <a:rPr lang="es-ES_tradnl" sz="2400" b="1" i="0" u="none" strike="noStrike" cap="none" dirty="0">
+                <a:solidFill>
+                  <a:srgbClr val="004AAD"/>
+                </a:solidFill>
+                <a:latin typeface="Poppins"/>
+                <a:ea typeface="Poppins"/>
+                <a:cs typeface="Poppins"/>
+                <a:sym typeface="Poppins"/>
+              </a:rPr>
+              <a:t>DESMITIFICACIÓN DE LA ANTIGÜEDAD</a:t>
+            </a:r>
+            <a:endParaRPr lang="es-ES_tradnl" dirty="0"/>
+          </a:p>
+        </p:txBody>
+      </p:sp>
+      <p:grpSp>
+        <p:nvGrpSpPr>
+          <p:cNvPr id="308" name="Google Shape;308;p23">
+            <a:extLst>
+              <a:ext uri="{FF2B5EF4-FFF2-40B4-BE49-F238E27FC236}">
+                <a16:creationId xmlns:a16="http://schemas.microsoft.com/office/drawing/2014/main" id="{B3C6E7B3-9D31-55CD-CA26-CF5430B1F92E}"/>
+              </a:ext>
+            </a:extLst>
+          </p:cNvPr>
+          <p:cNvGrpSpPr/>
+          <p:nvPr/>
+        </p:nvGrpSpPr>
+        <p:grpSpPr>
+          <a:xfrm>
+            <a:off x="0" y="5"/>
+            <a:ext cx="2163413" cy="1886345"/>
+            <a:chOff x="12784175" y="3675030"/>
+            <a:chExt cx="2163413" cy="1886345"/>
+          </a:xfrm>
+        </p:grpSpPr>
+        <p:sp>
+          <p:nvSpPr>
+            <p:cNvPr id="309" name="Google Shape;309;p23">
+              <a:extLst>
+                <a:ext uri="{FF2B5EF4-FFF2-40B4-BE49-F238E27FC236}">
+                  <a16:creationId xmlns:a16="http://schemas.microsoft.com/office/drawing/2014/main" id="{22DC04A7-9158-BB4E-F48C-FFFCB3796275}"/>
+                </a:ext>
+              </a:extLst>
+            </p:cNvPr>
+            <p:cNvSpPr txBox="1"/>
+            <p:nvPr/>
+          </p:nvSpPr>
+          <p:spPr>
+            <a:xfrm rot="1830973">
+              <a:off x="12805773" y="4425496"/>
+              <a:ext cx="2081405" cy="652657"/>
+            </a:xfrm>
+            <a:prstGeom prst="rect">
+              <a:avLst/>
+            </a:prstGeom>
+            <a:noFill/>
+            <a:ln>
+              <a:noFill/>
+            </a:ln>
+          </p:spPr>
+          <p:txBody>
+            <a:bodyPr spcFirstLastPara="1" wrap="square" lIns="91425" tIns="91425" rIns="91425" bIns="91425" anchor="t" anchorCtr="0">
+              <a:noAutofit/>
+            </a:bodyPr>
+            <a:lstStyle/>
+            <a:p>
+              <a:pPr marL="0" lvl="0" indent="0" algn="l" rtl="0">
+                <a:spcBef>
+                  <a:spcPts val="0"/>
+                </a:spcBef>
+                <a:spcAft>
+                  <a:spcPts val="0"/>
+                </a:spcAft>
+                <a:buNone/>
+              </a:pPr>
+              <a:r>
+                <a:rPr lang="es-ES_tradnl" sz="2300" b="1" i="1" dirty="0">
+                  <a:solidFill>
+                    <a:srgbClr val="E69138"/>
+                  </a:solidFill>
+                  <a:latin typeface="Calibri"/>
+                  <a:ea typeface="Calibri"/>
+                  <a:cs typeface="Calibri"/>
+                  <a:sym typeface="Calibri"/>
+                </a:rPr>
+                <a:t>RAPID EXPRESS </a:t>
+              </a:r>
+            </a:p>
+          </p:txBody>
+        </p:sp>
+        <p:sp>
+          <p:nvSpPr>
+            <p:cNvPr id="310" name="Google Shape;310;p23">
+              <a:extLst>
+                <a:ext uri="{FF2B5EF4-FFF2-40B4-BE49-F238E27FC236}">
+                  <a16:creationId xmlns:a16="http://schemas.microsoft.com/office/drawing/2014/main" id="{61FD26A3-7C65-7F64-5E8A-A0DC8DCC11F4}"/>
+                </a:ext>
+              </a:extLst>
+            </p:cNvPr>
+            <p:cNvSpPr/>
+            <p:nvPr/>
+          </p:nvSpPr>
+          <p:spPr>
+            <a:xfrm>
+              <a:off x="13335203" y="3675030"/>
+              <a:ext cx="1612385" cy="1275250"/>
+            </a:xfrm>
+            <a:custGeom>
+              <a:avLst/>
+              <a:gdLst/>
+              <a:ahLst/>
+              <a:cxnLst/>
+              <a:rect l="l" t="t" r="r" b="b"/>
+              <a:pathLst>
+                <a:path w="1612385" h="1275250" extrusionOk="0">
+                  <a:moveTo>
+                    <a:pt x="0" y="0"/>
+                  </a:moveTo>
+                  <a:lnTo>
+                    <a:pt x="1612384" y="0"/>
+                  </a:lnTo>
+                  <a:lnTo>
+                    <a:pt x="1612384" y="1275249"/>
+                  </a:lnTo>
+                  <a:lnTo>
+                    <a:pt x="0" y="1275249"/>
+                  </a:lnTo>
+                  <a:lnTo>
+                    <a:pt x="0" y="0"/>
+                  </a:lnTo>
+                  <a:close/>
+                </a:path>
+              </a:pathLst>
+            </a:custGeom>
+            <a:blipFill rotWithShape="1">
+              <a:blip r:embed="rId4">
+                <a:alphaModFix/>
+              </a:blip>
+              <a:stretch>
+                <a:fillRect/>
+              </a:stretch>
+            </a:blipFill>
+            <a:ln>
+              <a:noFill/>
+            </a:ln>
+          </p:spPr>
+          <p:txBody>
+            <a:bodyPr/>
+            <a:lstStyle/>
+            <a:p>
+              <a:endParaRPr lang="es-ES_tradnl" dirty="0"/>
+            </a:p>
+          </p:txBody>
+        </p:sp>
+      </p:grpSp>
+      <p:sp>
+        <p:nvSpPr>
+          <p:cNvPr id="20" name="Google Shape;162;p18">
+            <a:extLst>
+              <a:ext uri="{FF2B5EF4-FFF2-40B4-BE49-F238E27FC236}">
+                <a16:creationId xmlns:a16="http://schemas.microsoft.com/office/drawing/2014/main" id="{A239F5B4-C207-4A51-AE2F-F621521A6B0F}"/>
+              </a:ext>
+            </a:extLst>
+          </p:cNvPr>
+          <p:cNvSpPr/>
+          <p:nvPr/>
+        </p:nvSpPr>
+        <p:spPr>
+          <a:xfrm>
+            <a:off x="14226839" y="7928731"/>
+            <a:ext cx="2156379" cy="1936821"/>
+          </a:xfrm>
+          <a:custGeom>
+            <a:avLst/>
+            <a:gdLst/>
+            <a:ahLst/>
+            <a:cxnLst/>
+            <a:rect l="l" t="t" r="r" b="b"/>
+            <a:pathLst>
+              <a:path w="4469180" h="4014136" extrusionOk="0">
+                <a:moveTo>
+                  <a:pt x="0" y="0"/>
+                </a:moveTo>
+                <a:lnTo>
+                  <a:pt x="4469180" y="0"/>
+                </a:lnTo>
+                <a:lnTo>
+                  <a:pt x="4469180" y="4014136"/>
+                </a:lnTo>
+                <a:lnTo>
+                  <a:pt x="0" y="4014136"/>
+                </a:lnTo>
+                <a:lnTo>
+                  <a:pt x="0" y="0"/>
+                </a:lnTo>
+                <a:close/>
+              </a:path>
+            </a:pathLst>
+          </a:custGeom>
+          <a:blipFill rotWithShape="1">
+            <a:blip r:embed="rId5">
+              <a:alphaModFix/>
+            </a:blip>
+            <a:stretch>
+              <a:fillRect/>
+            </a:stretch>
+          </a:blipFill>
+          <a:ln>
+            <a:noFill/>
+          </a:ln>
+        </p:spPr>
+        <p:txBody>
+          <a:bodyPr/>
+          <a:lstStyle/>
+          <a:p>
+            <a:endParaRPr lang="es-ES_tradnl" dirty="0"/>
+          </a:p>
+        </p:txBody>
+      </p:sp>
+    </p:spTree>
+    <p:extLst>
+      <p:ext uri="{BB962C8B-B14F-4D97-AF65-F5344CB8AC3E}">
+        <p14:creationId xmlns:p14="http://schemas.microsoft.com/office/powerpoint/2010/main" val="1549375143"/>
+      </p:ext>
+    </p:extLst>
+  </p:cSld>
+  <p:clrMapOvr>
+    <a:masterClrMapping/>
+  </p:clrMapOvr>
+</p:sld>
+</file>
+
+<file path=ppt/slides/slide13.xml><?xml version="1.0" encoding="utf-8"?>
 <p:sld xmlns:a="http://schemas.openxmlformats.org/drawingml/2006/main" xmlns:r="http://schemas.openxmlformats.org/officeDocument/2006/relationships" xmlns:p="http://schemas.openxmlformats.org/presentationml/2006/main">
   <p:cSld>
     <p:bg>
@@ -15713,7 +16729,7 @@
 </p:sld>
 </file>
 
-<file path=ppt/slides/slide13.xml><?xml version="1.0" encoding="utf-8"?>
+<file path=ppt/slides/slide14.xml><?xml version="1.0" encoding="utf-8"?>
 <p:sld xmlns:a="http://schemas.openxmlformats.org/drawingml/2006/main" xmlns:r="http://schemas.openxmlformats.org/officeDocument/2006/relationships" xmlns:p="http://schemas.openxmlformats.org/presentationml/2006/main">
   <p:cSld>
     <p:bg>
@@ -16957,7 +17973,7 @@
 </p:sld>
 </file>
 
-<file path=ppt/slides/slide14.xml><?xml version="1.0" encoding="utf-8"?>
+<file path=ppt/slides/slide15.xml><?xml version="1.0" encoding="utf-8"?>
 <p:sld xmlns:a="http://schemas.openxmlformats.org/drawingml/2006/main" xmlns:r="http://schemas.openxmlformats.org/officeDocument/2006/relationships" xmlns:p="http://schemas.openxmlformats.org/presentationml/2006/main">
   <p:cSld>
     <p:bg>
@@ -17958,7 +18974,7 @@
 </p:sld>
 </file>
 
-<file path=ppt/slides/slide15.xml><?xml version="1.0" encoding="utf-8"?>
+<file path=ppt/slides/slide16.xml><?xml version="1.0" encoding="utf-8"?>
 <p:sld xmlns:a="http://schemas.openxmlformats.org/drawingml/2006/main" xmlns:r="http://schemas.openxmlformats.org/officeDocument/2006/relationships" xmlns:p="http://schemas.openxmlformats.org/presentationml/2006/main">
   <p:cSld>
     <p:bg>
@@ -18295,7 +19311,7 @@
 </p:sld>
 </file>
 
-<file path=ppt/slides/slide16.xml><?xml version="1.0" encoding="utf-8"?>
+<file path=ppt/slides/slide17.xml><?xml version="1.0" encoding="utf-8"?>
 <p:sld xmlns:a="http://schemas.openxmlformats.org/drawingml/2006/main" xmlns:r="http://schemas.openxmlformats.org/officeDocument/2006/relationships" xmlns:p="http://schemas.openxmlformats.org/presentationml/2006/main">
   <p:cSld>
     <p:bg>
@@ -19121,7 +20137,7 @@
 </p:sld>
 </file>
 
-<file path=ppt/slides/slide17.xml><?xml version="1.0" encoding="utf-8"?>
+<file path=ppt/slides/slide18.xml><?xml version="1.0" encoding="utf-8"?>
 <p:sld xmlns:a="http://schemas.openxmlformats.org/drawingml/2006/main" xmlns:r="http://schemas.openxmlformats.org/officeDocument/2006/relationships" xmlns:p="http://schemas.openxmlformats.org/presentationml/2006/main">
   <p:cSld>
     <p:bg>
@@ -21161,7 +22177,7 @@
 </p:sld>
 </file>
 
-<file path=ppt/slides/slide18.xml><?xml version="1.0" encoding="utf-8"?>
+<file path=ppt/slides/slide19.xml><?xml version="1.0" encoding="utf-8"?>
 <p:sld xmlns:a="http://schemas.openxmlformats.org/drawingml/2006/main" xmlns:r="http://schemas.openxmlformats.org/officeDocument/2006/relationships" xmlns:p="http://schemas.openxmlformats.org/presentationml/2006/main">
   <p:cSld>
     <p:bg>
@@ -23292,980 +24308,6 @@
     <p:extLst>
       <p:ext uri="{BB962C8B-B14F-4D97-AF65-F5344CB8AC3E}">
         <p14:creationId xmlns:p14="http://schemas.microsoft.com/office/powerpoint/2010/main" val="3044485445"/>
-      </p:ext>
-    </p:extLst>
-  </p:cSld>
-  <p:clrMapOvr>
-    <a:masterClrMapping/>
-  </p:clrMapOvr>
-</p:sld>
-</file>
-
-<file path=ppt/slides/slide19.xml><?xml version="1.0" encoding="utf-8"?>
-<p:sld xmlns:a="http://schemas.openxmlformats.org/drawingml/2006/main" xmlns:r="http://schemas.openxmlformats.org/officeDocument/2006/relationships" xmlns:p="http://schemas.openxmlformats.org/presentationml/2006/main">
-  <p:cSld>
-    <p:bg>
-      <p:bgPr>
-        <a:solidFill>
-          <a:srgbClr val="E0E9F9"/>
-        </a:solidFill>
-        <a:effectLst/>
-      </p:bgPr>
-    </p:bg>
-    <p:spTree>
-      <p:nvGrpSpPr>
-        <p:cNvPr id="1" name="Shape 280">
-          <a:extLst>
-            <a:ext uri="{FF2B5EF4-FFF2-40B4-BE49-F238E27FC236}">
-              <a16:creationId xmlns:a16="http://schemas.microsoft.com/office/drawing/2014/main" id="{9CF05CD1-42CF-1415-2507-014F0D5DAD6D}"/>
-            </a:ext>
-          </a:extLst>
-        </p:cNvPr>
-        <p:cNvGrpSpPr/>
-        <p:nvPr/>
-      </p:nvGrpSpPr>
-      <p:grpSpPr>
-        <a:xfrm>
-          <a:off x="0" y="0"/>
-          <a:ext cx="0" cy="0"/>
-          <a:chOff x="0" y="0"/>
-          <a:chExt cx="0" cy="0"/>
-        </a:xfrm>
-      </p:grpSpPr>
-      <p:grpSp>
-        <p:nvGrpSpPr>
-          <p:cNvPr id="281" name="Google Shape;281;p23">
-            <a:extLst>
-              <a:ext uri="{FF2B5EF4-FFF2-40B4-BE49-F238E27FC236}">
-                <a16:creationId xmlns:a16="http://schemas.microsoft.com/office/drawing/2014/main" id="{FBD2D488-777B-F881-321D-7414A6F7B18A}"/>
-              </a:ext>
-            </a:extLst>
-          </p:cNvPr>
-          <p:cNvGrpSpPr/>
-          <p:nvPr/>
-        </p:nvGrpSpPr>
-        <p:grpSpPr>
-          <a:xfrm>
-            <a:off x="8647101" y="1554020"/>
-            <a:ext cx="1382928" cy="1389712"/>
-            <a:chOff x="0" y="-9525"/>
-            <a:chExt cx="963809" cy="968537"/>
-          </a:xfrm>
-        </p:grpSpPr>
-        <p:sp>
-          <p:nvSpPr>
-            <p:cNvPr id="282" name="Google Shape;282;p23">
-              <a:extLst>
-                <a:ext uri="{FF2B5EF4-FFF2-40B4-BE49-F238E27FC236}">
-                  <a16:creationId xmlns:a16="http://schemas.microsoft.com/office/drawing/2014/main" id="{0904FE46-466E-A0FE-64A7-933E7269DDAC}"/>
-                </a:ext>
-              </a:extLst>
-            </p:cNvPr>
-            <p:cNvSpPr/>
-            <p:nvPr/>
-          </p:nvSpPr>
-          <p:spPr>
-            <a:xfrm>
-              <a:off x="0" y="0"/>
-              <a:ext cx="963809" cy="959012"/>
-            </a:xfrm>
-            <a:custGeom>
-              <a:avLst/>
-              <a:gdLst/>
-              <a:ahLst/>
-              <a:cxnLst/>
-              <a:rect l="l" t="t" r="r" b="b"/>
-              <a:pathLst>
-                <a:path w="963809" h="959012" extrusionOk="0">
-                  <a:moveTo>
-                    <a:pt x="0" y="0"/>
-                  </a:moveTo>
-                  <a:lnTo>
-                    <a:pt x="963809" y="0"/>
-                  </a:lnTo>
-                  <a:lnTo>
-                    <a:pt x="963809" y="959012"/>
-                  </a:lnTo>
-                  <a:lnTo>
-                    <a:pt x="0" y="959012"/>
-                  </a:lnTo>
-                  <a:close/>
-                </a:path>
-              </a:pathLst>
-            </a:custGeom>
-            <a:solidFill>
-              <a:srgbClr val="FFFFFF"/>
-            </a:solidFill>
-            <a:ln w="28575" cap="sq" cmpd="sng">
-              <a:solidFill>
-                <a:srgbClr val="004AAD"/>
-              </a:solidFill>
-              <a:prstDash val="solid"/>
-              <a:miter lim="8000"/>
-              <a:headEnd type="none" w="sm" len="sm"/>
-              <a:tailEnd type="none" w="sm" len="sm"/>
-            </a:ln>
-          </p:spPr>
-          <p:txBody>
-            <a:bodyPr/>
-            <a:lstStyle/>
-            <a:p>
-              <a:endParaRPr lang="es-ES_tradnl" dirty="0"/>
-            </a:p>
-          </p:txBody>
-        </p:sp>
-        <p:sp>
-          <p:nvSpPr>
-            <p:cNvPr id="283" name="Google Shape;283;p23">
-              <a:extLst>
-                <a:ext uri="{FF2B5EF4-FFF2-40B4-BE49-F238E27FC236}">
-                  <a16:creationId xmlns:a16="http://schemas.microsoft.com/office/drawing/2014/main" id="{35B35C79-17F9-73C2-E425-160AB7E1FED4}"/>
-                </a:ext>
-              </a:extLst>
-            </p:cNvPr>
-            <p:cNvSpPr txBox="1"/>
-            <p:nvPr/>
-          </p:nvSpPr>
-          <p:spPr>
-            <a:xfrm>
-              <a:off x="0" y="-9525"/>
-              <a:ext cx="963809" cy="968537"/>
-            </a:xfrm>
-            <a:prstGeom prst="rect">
-              <a:avLst/>
-            </a:prstGeom>
-            <a:noFill/>
-            <a:ln>
-              <a:noFill/>
-            </a:ln>
-          </p:spPr>
-          <p:txBody>
-            <a:bodyPr spcFirstLastPara="1" wrap="square" lIns="50800" tIns="50800" rIns="50800" bIns="50800" anchor="ctr" anchorCtr="0">
-              <a:noAutofit/>
-            </a:bodyPr>
-            <a:lstStyle/>
-            <a:p>
-              <a:pPr marL="0" marR="0" lvl="0" indent="0" algn="ctr" rtl="0">
-                <a:lnSpc>
-                  <a:spcPct val="113000"/>
-                </a:lnSpc>
-                <a:spcBef>
-                  <a:spcPts val="0"/>
-                </a:spcBef>
-                <a:spcAft>
-                  <a:spcPts val="0"/>
-                </a:spcAft>
-                <a:buNone/>
-              </a:pPr>
-              <a:r>
-                <a:rPr lang="es-ES_tradnl" sz="5000" b="1" i="0" u="none" strike="noStrike" cap="none" dirty="0">
-                  <a:solidFill>
-                    <a:srgbClr val="004AAD"/>
-                  </a:solidFill>
-                  <a:latin typeface="Poppins Black"/>
-                  <a:ea typeface="Poppins Black"/>
-                  <a:cs typeface="Poppins Black"/>
-                  <a:sym typeface="Poppins Black"/>
-                </a:rPr>
-                <a:t>1</a:t>
-              </a:r>
-              <a:endParaRPr lang="es-ES_tradnl" dirty="0"/>
-            </a:p>
-          </p:txBody>
-        </p:sp>
-      </p:grpSp>
-      <p:grpSp>
-        <p:nvGrpSpPr>
-          <p:cNvPr id="284" name="Google Shape;284;p23">
-            <a:extLst>
-              <a:ext uri="{FF2B5EF4-FFF2-40B4-BE49-F238E27FC236}">
-                <a16:creationId xmlns:a16="http://schemas.microsoft.com/office/drawing/2014/main" id="{D4DCD8B5-19F0-0D56-7A66-19EBF123EFC1}"/>
-              </a:ext>
-            </a:extLst>
-          </p:cNvPr>
-          <p:cNvGrpSpPr/>
-          <p:nvPr/>
-        </p:nvGrpSpPr>
-        <p:grpSpPr>
-          <a:xfrm>
-            <a:off x="8647101" y="3546536"/>
-            <a:ext cx="1382928" cy="1389712"/>
-            <a:chOff x="0" y="-9525"/>
-            <a:chExt cx="963809" cy="968537"/>
-          </a:xfrm>
-        </p:grpSpPr>
-        <p:sp>
-          <p:nvSpPr>
-            <p:cNvPr id="285" name="Google Shape;285;p23">
-              <a:extLst>
-                <a:ext uri="{FF2B5EF4-FFF2-40B4-BE49-F238E27FC236}">
-                  <a16:creationId xmlns:a16="http://schemas.microsoft.com/office/drawing/2014/main" id="{D9191FA8-EB35-68D8-CBB9-8124915F3660}"/>
-                </a:ext>
-              </a:extLst>
-            </p:cNvPr>
-            <p:cNvSpPr/>
-            <p:nvPr/>
-          </p:nvSpPr>
-          <p:spPr>
-            <a:xfrm>
-              <a:off x="0" y="0"/>
-              <a:ext cx="963809" cy="959012"/>
-            </a:xfrm>
-            <a:custGeom>
-              <a:avLst/>
-              <a:gdLst/>
-              <a:ahLst/>
-              <a:cxnLst/>
-              <a:rect l="l" t="t" r="r" b="b"/>
-              <a:pathLst>
-                <a:path w="963809" h="959012" extrusionOk="0">
-                  <a:moveTo>
-                    <a:pt x="0" y="0"/>
-                  </a:moveTo>
-                  <a:lnTo>
-                    <a:pt x="963809" y="0"/>
-                  </a:lnTo>
-                  <a:lnTo>
-                    <a:pt x="963809" y="959012"/>
-                  </a:lnTo>
-                  <a:lnTo>
-                    <a:pt x="0" y="959012"/>
-                  </a:lnTo>
-                  <a:close/>
-                </a:path>
-              </a:pathLst>
-            </a:custGeom>
-            <a:solidFill>
-              <a:srgbClr val="FFFFFF"/>
-            </a:solidFill>
-            <a:ln w="28575" cap="sq" cmpd="sng">
-              <a:solidFill>
-                <a:srgbClr val="004AAD"/>
-              </a:solidFill>
-              <a:prstDash val="solid"/>
-              <a:miter lim="8000"/>
-              <a:headEnd type="none" w="sm" len="sm"/>
-              <a:tailEnd type="none" w="sm" len="sm"/>
-            </a:ln>
-          </p:spPr>
-          <p:txBody>
-            <a:bodyPr/>
-            <a:lstStyle/>
-            <a:p>
-              <a:endParaRPr lang="es-ES_tradnl" dirty="0"/>
-            </a:p>
-          </p:txBody>
-        </p:sp>
-        <p:sp>
-          <p:nvSpPr>
-            <p:cNvPr id="286" name="Google Shape;286;p23">
-              <a:extLst>
-                <a:ext uri="{FF2B5EF4-FFF2-40B4-BE49-F238E27FC236}">
-                  <a16:creationId xmlns:a16="http://schemas.microsoft.com/office/drawing/2014/main" id="{5D2F282B-5CFE-6353-0E3A-8E7AC934BA03}"/>
-                </a:ext>
-              </a:extLst>
-            </p:cNvPr>
-            <p:cNvSpPr txBox="1"/>
-            <p:nvPr/>
-          </p:nvSpPr>
-          <p:spPr>
-            <a:xfrm>
-              <a:off x="0" y="-9525"/>
-              <a:ext cx="963809" cy="968537"/>
-            </a:xfrm>
-            <a:prstGeom prst="rect">
-              <a:avLst/>
-            </a:prstGeom>
-            <a:noFill/>
-            <a:ln>
-              <a:noFill/>
-            </a:ln>
-          </p:spPr>
-          <p:txBody>
-            <a:bodyPr spcFirstLastPara="1" wrap="square" lIns="50800" tIns="50800" rIns="50800" bIns="50800" anchor="ctr" anchorCtr="0">
-              <a:noAutofit/>
-            </a:bodyPr>
-            <a:lstStyle/>
-            <a:p>
-              <a:pPr marL="0" marR="0" lvl="0" indent="0" algn="ctr" rtl="0">
-                <a:lnSpc>
-                  <a:spcPct val="113000"/>
-                </a:lnSpc>
-                <a:spcBef>
-                  <a:spcPts val="0"/>
-                </a:spcBef>
-                <a:spcAft>
-                  <a:spcPts val="0"/>
-                </a:spcAft>
-                <a:buNone/>
-              </a:pPr>
-              <a:r>
-                <a:rPr lang="es-ES_tradnl" sz="5000" b="1" i="0" u="none" strike="noStrike" cap="none" dirty="0">
-                  <a:solidFill>
-                    <a:srgbClr val="004AAD"/>
-                  </a:solidFill>
-                  <a:latin typeface="Poppins Black"/>
-                  <a:ea typeface="Poppins Black"/>
-                  <a:cs typeface="Poppins Black"/>
-                  <a:sym typeface="Poppins Black"/>
-                </a:rPr>
-                <a:t>2</a:t>
-              </a:r>
-              <a:endParaRPr lang="es-ES_tradnl" dirty="0"/>
-            </a:p>
-          </p:txBody>
-        </p:sp>
-      </p:grpSp>
-      <p:grpSp>
-        <p:nvGrpSpPr>
-          <p:cNvPr id="287" name="Google Shape;287;p23">
-            <a:extLst>
-              <a:ext uri="{FF2B5EF4-FFF2-40B4-BE49-F238E27FC236}">
-                <a16:creationId xmlns:a16="http://schemas.microsoft.com/office/drawing/2014/main" id="{736B4F0E-699C-B9C6-CB17-B4A44D8566BE}"/>
-              </a:ext>
-            </a:extLst>
-          </p:cNvPr>
-          <p:cNvGrpSpPr/>
-          <p:nvPr/>
-        </p:nvGrpSpPr>
-        <p:grpSpPr>
-          <a:xfrm>
-            <a:off x="8647101" y="5578255"/>
-            <a:ext cx="1382928" cy="1389712"/>
-            <a:chOff x="0" y="-9525"/>
-            <a:chExt cx="963809" cy="968537"/>
-          </a:xfrm>
-        </p:grpSpPr>
-        <p:sp>
-          <p:nvSpPr>
-            <p:cNvPr id="288" name="Google Shape;288;p23">
-              <a:extLst>
-                <a:ext uri="{FF2B5EF4-FFF2-40B4-BE49-F238E27FC236}">
-                  <a16:creationId xmlns:a16="http://schemas.microsoft.com/office/drawing/2014/main" id="{534FAD3D-081E-452B-11A8-EF8FC4505649}"/>
-                </a:ext>
-              </a:extLst>
-            </p:cNvPr>
-            <p:cNvSpPr/>
-            <p:nvPr/>
-          </p:nvSpPr>
-          <p:spPr>
-            <a:xfrm>
-              <a:off x="0" y="0"/>
-              <a:ext cx="963809" cy="959012"/>
-            </a:xfrm>
-            <a:custGeom>
-              <a:avLst/>
-              <a:gdLst/>
-              <a:ahLst/>
-              <a:cxnLst/>
-              <a:rect l="l" t="t" r="r" b="b"/>
-              <a:pathLst>
-                <a:path w="963809" h="959012" extrusionOk="0">
-                  <a:moveTo>
-                    <a:pt x="0" y="0"/>
-                  </a:moveTo>
-                  <a:lnTo>
-                    <a:pt x="963809" y="0"/>
-                  </a:lnTo>
-                  <a:lnTo>
-                    <a:pt x="963809" y="959012"/>
-                  </a:lnTo>
-                  <a:lnTo>
-                    <a:pt x="0" y="959012"/>
-                  </a:lnTo>
-                  <a:close/>
-                </a:path>
-              </a:pathLst>
-            </a:custGeom>
-            <a:solidFill>
-              <a:srgbClr val="FFFFFF"/>
-            </a:solidFill>
-            <a:ln w="28575" cap="sq" cmpd="sng">
-              <a:solidFill>
-                <a:srgbClr val="004AAD"/>
-              </a:solidFill>
-              <a:prstDash val="solid"/>
-              <a:miter lim="8000"/>
-              <a:headEnd type="none" w="sm" len="sm"/>
-              <a:tailEnd type="none" w="sm" len="sm"/>
-            </a:ln>
-          </p:spPr>
-          <p:txBody>
-            <a:bodyPr/>
-            <a:lstStyle/>
-            <a:p>
-              <a:endParaRPr lang="es-ES_tradnl" dirty="0"/>
-            </a:p>
-          </p:txBody>
-        </p:sp>
-        <p:sp>
-          <p:nvSpPr>
-            <p:cNvPr id="289" name="Google Shape;289;p23">
-              <a:extLst>
-                <a:ext uri="{FF2B5EF4-FFF2-40B4-BE49-F238E27FC236}">
-                  <a16:creationId xmlns:a16="http://schemas.microsoft.com/office/drawing/2014/main" id="{F1D1B048-040C-1AF5-81F9-0F64D112826F}"/>
-                </a:ext>
-              </a:extLst>
-            </p:cNvPr>
-            <p:cNvSpPr txBox="1"/>
-            <p:nvPr/>
-          </p:nvSpPr>
-          <p:spPr>
-            <a:xfrm>
-              <a:off x="0" y="-9525"/>
-              <a:ext cx="963809" cy="968537"/>
-            </a:xfrm>
-            <a:prstGeom prst="rect">
-              <a:avLst/>
-            </a:prstGeom>
-            <a:noFill/>
-            <a:ln>
-              <a:noFill/>
-            </a:ln>
-          </p:spPr>
-          <p:txBody>
-            <a:bodyPr spcFirstLastPara="1" wrap="square" lIns="50800" tIns="50800" rIns="50800" bIns="50800" anchor="ctr" anchorCtr="0">
-              <a:noAutofit/>
-            </a:bodyPr>
-            <a:lstStyle/>
-            <a:p>
-              <a:pPr marL="0" marR="0" lvl="0" indent="0" algn="ctr" rtl="0">
-                <a:lnSpc>
-                  <a:spcPct val="113000"/>
-                </a:lnSpc>
-                <a:spcBef>
-                  <a:spcPts val="0"/>
-                </a:spcBef>
-                <a:spcAft>
-                  <a:spcPts val="0"/>
-                </a:spcAft>
-                <a:buNone/>
-              </a:pPr>
-              <a:r>
-                <a:rPr lang="es-ES_tradnl" sz="5000" b="1" i="0" u="none" strike="noStrike" cap="none" dirty="0">
-                  <a:solidFill>
-                    <a:srgbClr val="004AAD"/>
-                  </a:solidFill>
-                  <a:latin typeface="Poppins Black"/>
-                  <a:ea typeface="Poppins Black"/>
-                  <a:cs typeface="Poppins Black"/>
-                  <a:sym typeface="Poppins Black"/>
-                </a:rPr>
-                <a:t>3</a:t>
-              </a:r>
-              <a:endParaRPr lang="es-ES_tradnl" dirty="0"/>
-            </a:p>
-          </p:txBody>
-        </p:sp>
-      </p:grpSp>
-      <p:sp>
-        <p:nvSpPr>
-          <p:cNvPr id="293" name="Google Shape;293;p23">
-            <a:extLst>
-              <a:ext uri="{FF2B5EF4-FFF2-40B4-BE49-F238E27FC236}">
-                <a16:creationId xmlns:a16="http://schemas.microsoft.com/office/drawing/2014/main" id="{FFFE66FB-28AD-1476-E82E-46A9B8533C7C}"/>
-              </a:ext>
-            </a:extLst>
-          </p:cNvPr>
-          <p:cNvSpPr/>
-          <p:nvPr/>
-        </p:nvSpPr>
-        <p:spPr>
-          <a:xfrm>
-            <a:off x="-1518115" y="5138796"/>
-            <a:ext cx="7760440" cy="6137802"/>
-          </a:xfrm>
-          <a:custGeom>
-            <a:avLst/>
-            <a:gdLst/>
-            <a:ahLst/>
-            <a:cxnLst/>
-            <a:rect l="l" t="t" r="r" b="b"/>
-            <a:pathLst>
-              <a:path w="7760440" h="6137802" extrusionOk="0">
-                <a:moveTo>
-                  <a:pt x="0" y="0"/>
-                </a:moveTo>
-                <a:lnTo>
-                  <a:pt x="7760439" y="0"/>
-                </a:lnTo>
-                <a:lnTo>
-                  <a:pt x="7760439" y="6137802"/>
-                </a:lnTo>
-                <a:lnTo>
-                  <a:pt x="0" y="6137802"/>
-                </a:lnTo>
-                <a:lnTo>
-                  <a:pt x="0" y="0"/>
-                </a:lnTo>
-                <a:close/>
-              </a:path>
-            </a:pathLst>
-          </a:custGeom>
-          <a:blipFill rotWithShape="1">
-            <a:blip r:embed="rId3">
-              <a:alphaModFix/>
-            </a:blip>
-            <a:stretch>
-              <a:fillRect/>
-            </a:stretch>
-          </a:blipFill>
-          <a:ln>
-            <a:noFill/>
-          </a:ln>
-        </p:spPr>
-        <p:txBody>
-          <a:bodyPr/>
-          <a:lstStyle/>
-          <a:p>
-            <a:endParaRPr lang="es-ES_tradnl" dirty="0"/>
-          </a:p>
-        </p:txBody>
-      </p:sp>
-      <p:sp>
-        <p:nvSpPr>
-          <p:cNvPr id="294" name="Google Shape;294;p23">
-            <a:extLst>
-              <a:ext uri="{FF2B5EF4-FFF2-40B4-BE49-F238E27FC236}">
-                <a16:creationId xmlns:a16="http://schemas.microsoft.com/office/drawing/2014/main" id="{4335AF22-10B3-0245-6A1E-A7044BFDA00C}"/>
-              </a:ext>
-            </a:extLst>
-          </p:cNvPr>
-          <p:cNvSpPr txBox="1"/>
-          <p:nvPr/>
-        </p:nvSpPr>
-        <p:spPr>
-          <a:xfrm>
-            <a:off x="1357220" y="2067019"/>
-            <a:ext cx="5989500" cy="1341008"/>
-          </a:xfrm>
-          <a:prstGeom prst="rect">
-            <a:avLst/>
-          </a:prstGeom>
-          <a:noFill/>
-          <a:ln>
-            <a:noFill/>
-          </a:ln>
-        </p:spPr>
-        <p:txBody>
-          <a:bodyPr spcFirstLastPara="1" wrap="square" lIns="0" tIns="0" rIns="0" bIns="0" anchor="t" anchorCtr="0">
-            <a:spAutoFit/>
-          </a:bodyPr>
-          <a:lstStyle/>
-          <a:p>
-            <a:pPr marL="0" marR="0" lvl="0" indent="0" algn="l" rtl="0">
-              <a:lnSpc>
-                <a:spcPct val="121055"/>
-              </a:lnSpc>
-              <a:spcBef>
-                <a:spcPts val="0"/>
-              </a:spcBef>
-              <a:spcAft>
-                <a:spcPts val="0"/>
-              </a:spcAft>
-              <a:buNone/>
-            </a:pPr>
-            <a:r>
-              <a:rPr lang="es-ES_tradnl" sz="3601" b="1" dirty="0">
-                <a:solidFill>
-                  <a:srgbClr val="004AAD"/>
-                </a:solidFill>
-                <a:latin typeface="Poppins"/>
-                <a:ea typeface="Poppins"/>
-                <a:cs typeface="Poppins"/>
-                <a:sym typeface="Poppins"/>
-              </a:rPr>
-              <a:t>ESTRATEGIAS Y AJUSTES ORGANIZACIONALES</a:t>
-            </a:r>
-            <a:endParaRPr lang="es-ES_tradnl" dirty="0"/>
-          </a:p>
-        </p:txBody>
-      </p:sp>
-      <p:sp>
-        <p:nvSpPr>
-          <p:cNvPr id="298" name="Google Shape;298;p23">
-            <a:extLst>
-              <a:ext uri="{FF2B5EF4-FFF2-40B4-BE49-F238E27FC236}">
-                <a16:creationId xmlns:a16="http://schemas.microsoft.com/office/drawing/2014/main" id="{186A78B8-C8E3-38CC-833A-72225D4995D6}"/>
-              </a:ext>
-            </a:extLst>
-          </p:cNvPr>
-          <p:cNvSpPr txBox="1"/>
-          <p:nvPr/>
-        </p:nvSpPr>
-        <p:spPr>
-          <a:xfrm>
-            <a:off x="10393716" y="2031037"/>
-            <a:ext cx="5989502" cy="878959"/>
-          </a:xfrm>
-          <a:prstGeom prst="rect">
-            <a:avLst/>
-          </a:prstGeom>
-          <a:noFill/>
-          <a:ln>
-            <a:noFill/>
-          </a:ln>
-        </p:spPr>
-        <p:txBody>
-          <a:bodyPr spcFirstLastPara="1" wrap="square" lIns="0" tIns="0" rIns="0" bIns="0" anchor="t" anchorCtr="0">
-            <a:spAutoFit/>
-          </a:bodyPr>
-          <a:lstStyle/>
-          <a:p>
-            <a:pPr marL="0" marR="0" lvl="1" indent="0" algn="l" rtl="0">
-              <a:lnSpc>
-                <a:spcPct val="119000"/>
-              </a:lnSpc>
-              <a:spcBef>
-                <a:spcPts val="0"/>
-              </a:spcBef>
-              <a:spcAft>
-                <a:spcPts val="0"/>
-              </a:spcAft>
-              <a:buNone/>
-            </a:pPr>
-            <a:r>
-              <a:rPr lang="es-ES_tradnl" sz="2400" b="1" i="0" u="none" strike="noStrike" cap="none" dirty="0">
-                <a:solidFill>
-                  <a:srgbClr val="004AAD"/>
-                </a:solidFill>
-                <a:latin typeface="Poppins"/>
-                <a:ea typeface="Poppins"/>
-                <a:cs typeface="Poppins"/>
-                <a:sym typeface="Poppins"/>
-              </a:rPr>
-              <a:t>APLANAMIENTO DE LA CURVA DE TRABAJO</a:t>
-            </a:r>
-            <a:endParaRPr lang="es-ES_tradnl" dirty="0"/>
-          </a:p>
-        </p:txBody>
-      </p:sp>
-      <p:sp>
-        <p:nvSpPr>
-          <p:cNvPr id="301" name="Google Shape;301;p23">
-            <a:extLst>
-              <a:ext uri="{FF2B5EF4-FFF2-40B4-BE49-F238E27FC236}">
-                <a16:creationId xmlns:a16="http://schemas.microsoft.com/office/drawing/2014/main" id="{0EB0886F-3824-8864-5A8D-63D9B2DF248C}"/>
-              </a:ext>
-            </a:extLst>
-          </p:cNvPr>
-          <p:cNvSpPr txBox="1"/>
-          <p:nvPr/>
-        </p:nvSpPr>
-        <p:spPr>
-          <a:xfrm>
-            <a:off x="10393716" y="4021652"/>
-            <a:ext cx="5989502" cy="439479"/>
-          </a:xfrm>
-          <a:prstGeom prst="rect">
-            <a:avLst/>
-          </a:prstGeom>
-          <a:noFill/>
-          <a:ln>
-            <a:noFill/>
-          </a:ln>
-        </p:spPr>
-        <p:txBody>
-          <a:bodyPr spcFirstLastPara="1" wrap="square" lIns="0" tIns="0" rIns="0" bIns="0" anchor="t" anchorCtr="0">
-            <a:spAutoFit/>
-          </a:bodyPr>
-          <a:lstStyle/>
-          <a:p>
-            <a:pPr marL="0" marR="0" lvl="1" indent="0" algn="l" rtl="0">
-              <a:lnSpc>
-                <a:spcPct val="119000"/>
-              </a:lnSpc>
-              <a:spcBef>
-                <a:spcPts val="0"/>
-              </a:spcBef>
-              <a:spcAft>
-                <a:spcPts val="0"/>
-              </a:spcAft>
-              <a:buNone/>
-            </a:pPr>
-            <a:r>
-              <a:rPr lang="es-ES_tradnl" sz="2400" b="1" i="0" u="none" strike="noStrike" cap="none" dirty="0">
-                <a:solidFill>
-                  <a:srgbClr val="004AAD"/>
-                </a:solidFill>
-                <a:latin typeface="Poppins"/>
-                <a:ea typeface="Poppins"/>
-                <a:cs typeface="Poppins"/>
-                <a:sym typeface="Poppins"/>
-              </a:rPr>
-              <a:t>PLANIFICACIÓN ESTACIONAL</a:t>
-            </a:r>
-            <a:endParaRPr lang="es-ES_tradnl" dirty="0"/>
-          </a:p>
-        </p:txBody>
-      </p:sp>
-      <p:sp>
-        <p:nvSpPr>
-          <p:cNvPr id="304" name="Google Shape;304;p23">
-            <a:extLst>
-              <a:ext uri="{FF2B5EF4-FFF2-40B4-BE49-F238E27FC236}">
-                <a16:creationId xmlns:a16="http://schemas.microsoft.com/office/drawing/2014/main" id="{D81F7156-2EA7-892B-78D9-A6A96CEF51FB}"/>
-              </a:ext>
-            </a:extLst>
-          </p:cNvPr>
-          <p:cNvSpPr txBox="1"/>
-          <p:nvPr/>
-        </p:nvSpPr>
-        <p:spPr>
-          <a:xfrm>
-            <a:off x="10393716" y="6053371"/>
-            <a:ext cx="5989502" cy="439479"/>
-          </a:xfrm>
-          <a:prstGeom prst="rect">
-            <a:avLst/>
-          </a:prstGeom>
-          <a:noFill/>
-          <a:ln>
-            <a:noFill/>
-          </a:ln>
-        </p:spPr>
-        <p:txBody>
-          <a:bodyPr spcFirstLastPara="1" wrap="square" lIns="0" tIns="0" rIns="0" bIns="0" anchor="t" anchorCtr="0">
-            <a:spAutoFit/>
-          </a:bodyPr>
-          <a:lstStyle/>
-          <a:p>
-            <a:pPr marL="0" marR="0" lvl="1" indent="0" algn="l" rtl="0">
-              <a:lnSpc>
-                <a:spcPct val="119000"/>
-              </a:lnSpc>
-              <a:spcBef>
-                <a:spcPts val="0"/>
-              </a:spcBef>
-              <a:spcAft>
-                <a:spcPts val="0"/>
-              </a:spcAft>
-              <a:buNone/>
-            </a:pPr>
-            <a:r>
-              <a:rPr lang="es-ES_tradnl" sz="2400" b="1" i="0" u="none" strike="noStrike" cap="none" dirty="0">
-                <a:solidFill>
-                  <a:srgbClr val="004AAD"/>
-                </a:solidFill>
-                <a:latin typeface="Poppins"/>
-                <a:ea typeface="Poppins"/>
-                <a:cs typeface="Poppins"/>
-                <a:sym typeface="Poppins"/>
-              </a:rPr>
-              <a:t>DESMITIFICACIÓN DE LA ANTIGÜEDAD</a:t>
-            </a:r>
-            <a:endParaRPr lang="es-ES_tradnl" dirty="0"/>
-          </a:p>
-        </p:txBody>
-      </p:sp>
-      <p:grpSp>
-        <p:nvGrpSpPr>
-          <p:cNvPr id="308" name="Google Shape;308;p23">
-            <a:extLst>
-              <a:ext uri="{FF2B5EF4-FFF2-40B4-BE49-F238E27FC236}">
-                <a16:creationId xmlns:a16="http://schemas.microsoft.com/office/drawing/2014/main" id="{B3C6E7B3-9D31-55CD-CA26-CF5430B1F92E}"/>
-              </a:ext>
-            </a:extLst>
-          </p:cNvPr>
-          <p:cNvGrpSpPr/>
-          <p:nvPr/>
-        </p:nvGrpSpPr>
-        <p:grpSpPr>
-          <a:xfrm>
-            <a:off x="0" y="5"/>
-            <a:ext cx="2163413" cy="1886345"/>
-            <a:chOff x="12784175" y="3675030"/>
-            <a:chExt cx="2163413" cy="1886345"/>
-          </a:xfrm>
-        </p:grpSpPr>
-        <p:sp>
-          <p:nvSpPr>
-            <p:cNvPr id="309" name="Google Shape;309;p23">
-              <a:extLst>
-                <a:ext uri="{FF2B5EF4-FFF2-40B4-BE49-F238E27FC236}">
-                  <a16:creationId xmlns:a16="http://schemas.microsoft.com/office/drawing/2014/main" id="{22DC04A7-9158-BB4E-F48C-FFFCB3796275}"/>
-                </a:ext>
-              </a:extLst>
-            </p:cNvPr>
-            <p:cNvSpPr txBox="1"/>
-            <p:nvPr/>
-          </p:nvSpPr>
-          <p:spPr>
-            <a:xfrm rot="1830973">
-              <a:off x="12805773" y="4425496"/>
-              <a:ext cx="2081405" cy="652657"/>
-            </a:xfrm>
-            <a:prstGeom prst="rect">
-              <a:avLst/>
-            </a:prstGeom>
-            <a:noFill/>
-            <a:ln>
-              <a:noFill/>
-            </a:ln>
-          </p:spPr>
-          <p:txBody>
-            <a:bodyPr spcFirstLastPara="1" wrap="square" lIns="91425" tIns="91425" rIns="91425" bIns="91425" anchor="t" anchorCtr="0">
-              <a:noAutofit/>
-            </a:bodyPr>
-            <a:lstStyle/>
-            <a:p>
-              <a:pPr marL="0" lvl="0" indent="0" algn="l" rtl="0">
-                <a:spcBef>
-                  <a:spcPts val="0"/>
-                </a:spcBef>
-                <a:spcAft>
-                  <a:spcPts val="0"/>
-                </a:spcAft>
-                <a:buNone/>
-              </a:pPr>
-              <a:r>
-                <a:rPr lang="es-ES_tradnl" sz="2300" b="1" i="1" dirty="0">
-                  <a:solidFill>
-                    <a:srgbClr val="E69138"/>
-                  </a:solidFill>
-                  <a:latin typeface="Calibri"/>
-                  <a:ea typeface="Calibri"/>
-                  <a:cs typeface="Calibri"/>
-                  <a:sym typeface="Calibri"/>
-                </a:rPr>
-                <a:t>RAPID EXPRESS </a:t>
-              </a:r>
-            </a:p>
-          </p:txBody>
-        </p:sp>
-        <p:sp>
-          <p:nvSpPr>
-            <p:cNvPr id="310" name="Google Shape;310;p23">
-              <a:extLst>
-                <a:ext uri="{FF2B5EF4-FFF2-40B4-BE49-F238E27FC236}">
-                  <a16:creationId xmlns:a16="http://schemas.microsoft.com/office/drawing/2014/main" id="{61FD26A3-7C65-7F64-5E8A-A0DC8DCC11F4}"/>
-                </a:ext>
-              </a:extLst>
-            </p:cNvPr>
-            <p:cNvSpPr/>
-            <p:nvPr/>
-          </p:nvSpPr>
-          <p:spPr>
-            <a:xfrm>
-              <a:off x="13335203" y="3675030"/>
-              <a:ext cx="1612385" cy="1275250"/>
-            </a:xfrm>
-            <a:custGeom>
-              <a:avLst/>
-              <a:gdLst/>
-              <a:ahLst/>
-              <a:cxnLst/>
-              <a:rect l="l" t="t" r="r" b="b"/>
-              <a:pathLst>
-                <a:path w="1612385" h="1275250" extrusionOk="0">
-                  <a:moveTo>
-                    <a:pt x="0" y="0"/>
-                  </a:moveTo>
-                  <a:lnTo>
-                    <a:pt x="1612384" y="0"/>
-                  </a:lnTo>
-                  <a:lnTo>
-                    <a:pt x="1612384" y="1275249"/>
-                  </a:lnTo>
-                  <a:lnTo>
-                    <a:pt x="0" y="1275249"/>
-                  </a:lnTo>
-                  <a:lnTo>
-                    <a:pt x="0" y="0"/>
-                  </a:lnTo>
-                  <a:close/>
-                </a:path>
-              </a:pathLst>
-            </a:custGeom>
-            <a:blipFill rotWithShape="1">
-              <a:blip r:embed="rId4">
-                <a:alphaModFix/>
-              </a:blip>
-              <a:stretch>
-                <a:fillRect/>
-              </a:stretch>
-            </a:blipFill>
-            <a:ln>
-              <a:noFill/>
-            </a:ln>
-          </p:spPr>
-          <p:txBody>
-            <a:bodyPr/>
-            <a:lstStyle/>
-            <a:p>
-              <a:endParaRPr lang="es-ES_tradnl" dirty="0"/>
-            </a:p>
-          </p:txBody>
-        </p:sp>
-      </p:grpSp>
-      <p:sp>
-        <p:nvSpPr>
-          <p:cNvPr id="20" name="Google Shape;162;p18">
-            <a:extLst>
-              <a:ext uri="{FF2B5EF4-FFF2-40B4-BE49-F238E27FC236}">
-                <a16:creationId xmlns:a16="http://schemas.microsoft.com/office/drawing/2014/main" id="{A239F5B4-C207-4A51-AE2F-F621521A6B0F}"/>
-              </a:ext>
-            </a:extLst>
-          </p:cNvPr>
-          <p:cNvSpPr/>
-          <p:nvPr/>
-        </p:nvSpPr>
-        <p:spPr>
-          <a:xfrm>
-            <a:off x="14226839" y="7928731"/>
-            <a:ext cx="2156379" cy="1936821"/>
-          </a:xfrm>
-          <a:custGeom>
-            <a:avLst/>
-            <a:gdLst/>
-            <a:ahLst/>
-            <a:cxnLst/>
-            <a:rect l="l" t="t" r="r" b="b"/>
-            <a:pathLst>
-              <a:path w="4469180" h="4014136" extrusionOk="0">
-                <a:moveTo>
-                  <a:pt x="0" y="0"/>
-                </a:moveTo>
-                <a:lnTo>
-                  <a:pt x="4469180" y="0"/>
-                </a:lnTo>
-                <a:lnTo>
-                  <a:pt x="4469180" y="4014136"/>
-                </a:lnTo>
-                <a:lnTo>
-                  <a:pt x="0" y="4014136"/>
-                </a:lnTo>
-                <a:lnTo>
-                  <a:pt x="0" y="0"/>
-                </a:lnTo>
-                <a:close/>
-              </a:path>
-            </a:pathLst>
-          </a:custGeom>
-          <a:blipFill rotWithShape="1">
-            <a:blip r:embed="rId5">
-              <a:alphaModFix/>
-            </a:blip>
-            <a:stretch>
-              <a:fillRect/>
-            </a:stretch>
-          </a:blipFill>
-          <a:ln>
-            <a:noFill/>
-          </a:ln>
-        </p:spPr>
-        <p:txBody>
-          <a:bodyPr/>
-          <a:lstStyle/>
-          <a:p>
-            <a:endParaRPr lang="es-ES_tradnl" dirty="0"/>
-          </a:p>
-        </p:txBody>
-      </p:sp>
-    </p:spTree>
-    <p:extLst>
-      <p:ext uri="{BB962C8B-B14F-4D97-AF65-F5344CB8AC3E}">
-        <p14:creationId xmlns:p14="http://schemas.microsoft.com/office/powerpoint/2010/main" val="1549375143"/>
       </p:ext>
     </p:extLst>
   </p:cSld>
@@ -34778,6 +34820,48 @@
           </a:prstGeom>
         </p:spPr>
       </p:pic>
+      <p:sp>
+        <p:nvSpPr>
+          <p:cNvPr id="2" name="QuadreDeText 1">
+            <a:extLst>
+              <a:ext uri="{FF2B5EF4-FFF2-40B4-BE49-F238E27FC236}">
+                <a16:creationId xmlns:a16="http://schemas.microsoft.com/office/drawing/2014/main" id="{2BEC3BD1-E06F-4A88-94A2-80FFCE6D4F87}"/>
+              </a:ext>
+            </a:extLst>
+          </p:cNvPr>
+          <p:cNvSpPr txBox="1"/>
+          <p:nvPr/>
+        </p:nvSpPr>
+        <p:spPr>
+          <a:xfrm>
+            <a:off x="11287593" y="9458793"/>
+            <a:ext cx="6045245" cy="307777"/>
+          </a:xfrm>
+          <a:prstGeom prst="rect">
+            <a:avLst/>
+          </a:prstGeom>
+          <a:noFill/>
+        </p:spPr>
+        <p:txBody>
+          <a:bodyPr wrap="none" rtlCol="0">
+            <a:spAutoFit/>
+          </a:bodyPr>
+          <a:lstStyle/>
+          <a:p>
+            <a:r>
+              <a:rPr lang="es-ES" dirty="0"/>
+              <a:t>Fuente: </a:t>
+            </a:r>
+            <a:r>
+              <a:rPr lang="es-ES" dirty="0">
+                <a:hlinkClick r:id="rId6"/>
+              </a:rPr>
+              <a:t>Encuesta Anual Laboral. Ministerio de Trabajo y Economía Social</a:t>
+            </a:r>
+            <a:endParaRPr lang="es-ES" dirty="0"/>
+          </a:p>
+        </p:txBody>
+      </p:sp>
     </p:spTree>
   </p:cSld>
   <p:clrMapOvr>
@@ -35188,6 +35272,48 @@
           </a:p>
         </p:txBody>
       </p:sp>
+      <p:sp>
+        <p:nvSpPr>
+          <p:cNvPr id="13" name="QuadreDeText 12">
+            <a:extLst>
+              <a:ext uri="{FF2B5EF4-FFF2-40B4-BE49-F238E27FC236}">
+                <a16:creationId xmlns:a16="http://schemas.microsoft.com/office/drawing/2014/main" id="{EC4ED6EC-FC33-4F3E-B445-1FDB1C856B6A}"/>
+              </a:ext>
+            </a:extLst>
+          </p:cNvPr>
+          <p:cNvSpPr txBox="1"/>
+          <p:nvPr/>
+        </p:nvSpPr>
+        <p:spPr>
+          <a:xfrm>
+            <a:off x="11172881" y="9454919"/>
+            <a:ext cx="9173980" cy="307777"/>
+          </a:xfrm>
+          <a:prstGeom prst="rect">
+            <a:avLst/>
+          </a:prstGeom>
+          <a:noFill/>
+        </p:spPr>
+        <p:txBody>
+          <a:bodyPr wrap="square">
+            <a:spAutoFit/>
+          </a:bodyPr>
+          <a:lstStyle/>
+          <a:p>
+            <a:r>
+              <a:rPr lang="es-ES" dirty="0"/>
+              <a:t>Fuente: </a:t>
+            </a:r>
+            <a:r>
+              <a:rPr lang="es-ES" dirty="0">
+                <a:hlinkClick r:id="rId6"/>
+              </a:rPr>
+              <a:t>Encuesta Anual Laboral. Ministerio de Trabajo y Economía Social</a:t>
+            </a:r>
+            <a:endParaRPr lang="es-ES" dirty="0"/>
+          </a:p>
+        </p:txBody>
+      </p:sp>
     </p:spTree>
     <p:extLst>
       <p:ext uri="{BB962C8B-B14F-4D97-AF65-F5344CB8AC3E}">
@@ -35603,6 +35729,48 @@
           </a:p>
         </p:txBody>
       </p:sp>
+      <p:sp>
+        <p:nvSpPr>
+          <p:cNvPr id="13" name="QuadreDeText 12">
+            <a:extLst>
+              <a:ext uri="{FF2B5EF4-FFF2-40B4-BE49-F238E27FC236}">
+                <a16:creationId xmlns:a16="http://schemas.microsoft.com/office/drawing/2014/main" id="{5196AD66-857B-445F-8ACA-8B5866848235}"/>
+              </a:ext>
+            </a:extLst>
+          </p:cNvPr>
+          <p:cNvSpPr txBox="1"/>
+          <p:nvPr/>
+        </p:nvSpPr>
+        <p:spPr>
+          <a:xfrm>
+            <a:off x="10598046" y="9157862"/>
+            <a:ext cx="9173980" cy="307777"/>
+          </a:xfrm>
+          <a:prstGeom prst="rect">
+            <a:avLst/>
+          </a:prstGeom>
+          <a:noFill/>
+        </p:spPr>
+        <p:txBody>
+          <a:bodyPr wrap="square">
+            <a:spAutoFit/>
+          </a:bodyPr>
+          <a:lstStyle/>
+          <a:p>
+            <a:r>
+              <a:rPr lang="es-ES" dirty="0"/>
+              <a:t>Fuente: </a:t>
+            </a:r>
+            <a:r>
+              <a:rPr lang="es-ES" dirty="0">
+                <a:hlinkClick r:id="rId6"/>
+              </a:rPr>
+              <a:t>Encuesta Anual Laboral. Ministerio de Trabajo y Economía Social</a:t>
+            </a:r>
+            <a:endParaRPr lang="es-ES" dirty="0"/>
+          </a:p>
+        </p:txBody>
+      </p:sp>
     </p:spTree>
     <p:extLst>
       <p:ext uri="{BB962C8B-B14F-4D97-AF65-F5344CB8AC3E}">
@@ -35964,6 +36132,48 @@
           </a:p>
         </p:txBody>
       </p:sp>
+      <p:sp>
+        <p:nvSpPr>
+          <p:cNvPr id="10" name="QuadreDeText 9">
+            <a:extLst>
+              <a:ext uri="{FF2B5EF4-FFF2-40B4-BE49-F238E27FC236}">
+                <a16:creationId xmlns:a16="http://schemas.microsoft.com/office/drawing/2014/main" id="{BFD99AF1-9DAA-451E-83AF-1058AB19BE6B}"/>
+              </a:ext>
+            </a:extLst>
+          </p:cNvPr>
+          <p:cNvSpPr txBox="1"/>
+          <p:nvPr/>
+        </p:nvSpPr>
+        <p:spPr>
+          <a:xfrm>
+            <a:off x="11587397" y="9295283"/>
+            <a:ext cx="9173980" cy="307777"/>
+          </a:xfrm>
+          <a:prstGeom prst="rect">
+            <a:avLst/>
+          </a:prstGeom>
+          <a:noFill/>
+        </p:spPr>
+        <p:txBody>
+          <a:bodyPr wrap="square">
+            <a:spAutoFit/>
+          </a:bodyPr>
+          <a:lstStyle/>
+          <a:p>
+            <a:r>
+              <a:rPr lang="es-ES" dirty="0"/>
+              <a:t>Fuente: </a:t>
+            </a:r>
+            <a:r>
+              <a:rPr lang="es-ES" dirty="0">
+                <a:hlinkClick r:id="rId6"/>
+              </a:rPr>
+              <a:t>Encuesta Anual Laboral. Ministerio de Trabajo y Economía Social</a:t>
+            </a:r>
+            <a:endParaRPr lang="es-ES" dirty="0"/>
+          </a:p>
+        </p:txBody>
+      </p:sp>
     </p:spTree>
     <p:extLst>
       <p:ext uri="{BB962C8B-B14F-4D97-AF65-F5344CB8AC3E}">
@@ -36370,6 +36580,48 @@
           <a:p>
             <a:pPr algn="ctr"/>
             <a:endParaRPr lang="es-ES"/>
+          </a:p>
+        </p:txBody>
+      </p:sp>
+      <p:sp>
+        <p:nvSpPr>
+          <p:cNvPr id="10" name="QuadreDeText 9">
+            <a:extLst>
+              <a:ext uri="{FF2B5EF4-FFF2-40B4-BE49-F238E27FC236}">
+                <a16:creationId xmlns:a16="http://schemas.microsoft.com/office/drawing/2014/main" id="{78EA8AD0-7D3A-4D72-BC07-3134E7C59809}"/>
+              </a:ext>
+            </a:extLst>
+          </p:cNvPr>
+          <p:cNvSpPr txBox="1"/>
+          <p:nvPr/>
+        </p:nvSpPr>
+        <p:spPr>
+          <a:xfrm>
+            <a:off x="12037101" y="9762696"/>
+            <a:ext cx="9173980" cy="307777"/>
+          </a:xfrm>
+          <a:prstGeom prst="rect">
+            <a:avLst/>
+          </a:prstGeom>
+          <a:noFill/>
+        </p:spPr>
+        <p:txBody>
+          <a:bodyPr wrap="square">
+            <a:spAutoFit/>
+          </a:bodyPr>
+          <a:lstStyle/>
+          <a:p>
+            <a:r>
+              <a:rPr lang="es-ES" dirty="0"/>
+              <a:t>Fuente: </a:t>
+            </a:r>
+            <a:r>
+              <a:rPr lang="es-ES" dirty="0">
+                <a:hlinkClick r:id="rId6"/>
+              </a:rPr>
+              <a:t>Encuesta Anual Laboral. Ministerio de Trabajo y Economía Social</a:t>
+            </a:r>
+            <a:endParaRPr lang="es-ES" dirty="0"/>
           </a:p>
         </p:txBody>
       </p:sp>

</xml_diff>